<commit_message>
docs(submission): add verifiable rubric evidence
Replace broad achievement claims with a machine-checked BR and objective evidence contract, a current OWASP verification matrix, and a defensible DynamoDB alternative design.

Update the secure-coding report and demonstration deck with the implemented four-station workflow, an honest projected rubric score, and explicit field-measurement gaps.

Change authored by GPT-5.6-Sol through T3 Code.
</commit_message>
<xml_diff>
--- a/docs/04-Security/secure_coding/final/VSMS_Demonstration.pptx
+++ b/docs/04-Security/secure_coding/final/VSMS_Demonstration.pptx
@@ -2,23 +2,24 @@
 <file path=ppt/presentation.xml><?xml version="1.0" encoding="utf-8"?>
 <p:presentation xmlns:p="http://schemas.openxmlformats.org/presentationml/2006/main">
   <p:sldMasterIdLst>
-    <p:sldMasterId xmlns:r="http://schemas.openxmlformats.org/officeDocument/2006/relationships" id="2147483648" r:id="Ra4dedfe9c85a4f98"/>
+    <p:sldMasterId xmlns:r="http://schemas.openxmlformats.org/officeDocument/2006/relationships" id="2147483648" r:id="R6e0d2671a5694702"/>
   </p:sldMasterIdLst>
   <p:notesMasterIdLst>
-    <p:notesMasterId xmlns:r="http://schemas.openxmlformats.org/officeDocument/2006/relationships" r:id="R0ab33d691f7448aa"/>
+    <p:notesMasterId xmlns:r="http://schemas.openxmlformats.org/officeDocument/2006/relationships" r:id="Rcb5478ef402349a0"/>
   </p:notesMasterIdLst>
   <p:sldIdLst>
-    <p:sldId xmlns:r="http://schemas.openxmlformats.org/officeDocument/2006/relationships" id="256" r:id="Rb5f0ac7b51274465"/>
-    <p:sldId xmlns:r="http://schemas.openxmlformats.org/officeDocument/2006/relationships" id="257" r:id="Rc6cb8a88e2904bc0"/>
-    <p:sldId xmlns:r="http://schemas.openxmlformats.org/officeDocument/2006/relationships" id="258" r:id="R1327fe8db410480c"/>
-    <p:sldId xmlns:r="http://schemas.openxmlformats.org/officeDocument/2006/relationships" id="259" r:id="Rb56b0188821b4577"/>
-    <p:sldId xmlns:r="http://schemas.openxmlformats.org/officeDocument/2006/relationships" id="260" r:id="R70f71eca91954e62"/>
-    <p:sldId xmlns:r="http://schemas.openxmlformats.org/officeDocument/2006/relationships" id="261" r:id="Rc92f02c85d144815"/>
-    <p:sldId xmlns:r="http://schemas.openxmlformats.org/officeDocument/2006/relationships" id="262" r:id="Racf5fe81d91e41a2"/>
-    <p:sldId xmlns:r="http://schemas.openxmlformats.org/officeDocument/2006/relationships" id="263" r:id="Re18c6df8175949a5"/>
-    <p:sldId xmlns:r="http://schemas.openxmlformats.org/officeDocument/2006/relationships" id="264" r:id="R98cac2df860644ad"/>
-    <p:sldId xmlns:r="http://schemas.openxmlformats.org/officeDocument/2006/relationships" id="265" r:id="R38af5c6d0e814ce0"/>
-    <p:sldId xmlns:r="http://schemas.openxmlformats.org/officeDocument/2006/relationships" id="266" r:id="R7fe6fb7a04c94c32"/>
+    <p:sldId xmlns:r="http://schemas.openxmlformats.org/officeDocument/2006/relationships" id="256" r:id="R6251250d7e854ff1"/>
+    <p:sldId xmlns:r="http://schemas.openxmlformats.org/officeDocument/2006/relationships" id="257" r:id="R0f188d2306f641fe"/>
+    <p:sldId xmlns:r="http://schemas.openxmlformats.org/officeDocument/2006/relationships" id="258" r:id="Rbbcd8f6b39e448c8"/>
+    <p:sldId xmlns:r="http://schemas.openxmlformats.org/officeDocument/2006/relationships" id="259" r:id="R7f1672c9bb934477"/>
+    <p:sldId xmlns:r="http://schemas.openxmlformats.org/officeDocument/2006/relationships" id="260" r:id="R052a720c590f4a0c"/>
+    <p:sldId xmlns:r="http://schemas.openxmlformats.org/officeDocument/2006/relationships" id="261" r:id="Rd7ff923dc4b744a8"/>
+    <p:sldId xmlns:r="http://schemas.openxmlformats.org/officeDocument/2006/relationships" id="262" r:id="R5df8add43e0046bc"/>
+    <p:sldId xmlns:r="http://schemas.openxmlformats.org/officeDocument/2006/relationships" id="263" r:id="Rdcf68805b2c04f11"/>
+    <p:sldId xmlns:r="http://schemas.openxmlformats.org/officeDocument/2006/relationships" id="264" r:id="Rddcef637e91f4af0"/>
+    <p:sldId xmlns:r="http://schemas.openxmlformats.org/officeDocument/2006/relationships" id="265" r:id="R4ccfdef2b0b3439e"/>
+    <p:sldId xmlns:r="http://schemas.openxmlformats.org/officeDocument/2006/relationships" id="266" r:id="Rc97ecfcb5460414b"/>
+    <p:sldId xmlns:r="http://schemas.openxmlformats.org/officeDocument/2006/relationships" id="267" r:id="R530218ba81e2481e"/>
   </p:sldIdLst>
   <p:sldSz cx="12192000" cy="6858000"/>
   <p:notesSz cx="6858000" cy="9144000"/>
@@ -637,6 +638,111 @@
           <a:lstStyle xmlns:a="http://schemas.openxmlformats.org/drawingml/2006/main"/>
           <a:p xmlns:a="http://schemas.openxmlformats.org/drawingml/2006/main">
             <a:r>
+              <a:t>This scorecard links requirements and objectives to repeatable repository evidence.</a:t>
+            </a:r>
+          </a:p>
+          <a:p xmlns:a="http://schemas.openxmlformats.org/drawingml/2006/main">
+            <a:r>
+              <a:t>The 50% registration, 90% paperwork, and 30% throughput targets still require a timed event baseline before they may be claimed as achieved.</a:t>
+            </a:r>
+          </a:p>
+          <a:p xmlns:a="http://schemas.openxmlformats.org/drawingml/2006/main">
+            <a:r>
+              <a:t/>
+            </a:r>
+          </a:p>
+          <a:p xmlns:a="http://schemas.openxmlformats.org/drawingml/2006/main">
+            <a:r>
+              <a:t>[Sources]</a:t>
+            </a:r>
+          </a:p>
+          <a:p xmlns:a="http://schemas.openxmlformats.org/drawingml/2006/main">
+            <a:r>
+              <a:t>- docs/09-Evidence/business-objectives.json</a:t>
+            </a:r>
+          </a:p>
+          <a:p xmlns:a="http://schemas.openxmlformats.org/drawingml/2006/main">
+            <a:r>
+              <a:t>- scripts/check-rubric-evidence.cjs</a:t>
+            </a:r>
+          </a:p>
+          <a:p xmlns:a="http://schemas.openxmlformats.org/drawingml/2006/main">
+            <a:r>
+              <a:t>- docs/04-Security/owasp-verification-matrix.md</a:t>
+            </a:r>
+          </a:p>
+          <a:p xmlns:a="http://schemas.openxmlformats.org/drawingml/2006/main">
+            <a:r>
+              <a:t>- Docker validation completed 2026-08-13</a:t>
+            </a:r>
+          </a:p>
+        </p:txBody>
+      </p:sp>
+      <p:sp>
+        <p:nvSpPr>
+          <p:cNvPr id="4" name="Slide Number Placeholder 3"/>
+          <p:cNvSpPr>
+            <a:spLocks xmlns:a="http://schemas.openxmlformats.org/drawingml/2006/main" noGrp="1"/>
+          </p:cNvSpPr>
+          <p:nvPr>
+            <p:ph type="sldNum" idx="5"/>
+          </p:nvPr>
+        </p:nvSpPr>
+        <p:spPr/>
+        <p:txBody>
+          <a:bodyPr xmlns:a="http://schemas.openxmlformats.org/drawingml/2006/main"/>
+          <a:lstStyle xmlns:a="http://schemas.openxmlformats.org/drawingml/2006/main"/>
+          <a:p xmlns:a="http://schemas.openxmlformats.org/drawingml/2006/main"/>
+        </p:txBody>
+      </p:sp>
+    </p:spTree>
+  </p:cSld>
+  <p:clrMapOvr>
+    <a:masterClrMapping xmlns:a="http://schemas.openxmlformats.org/drawingml/2006/main"/>
+  </p:clrMapOvr>
+</p:notes>
+</file>
+
+<file path=ppt/notesSlides/notesSlide12.xml><?xml version="1.0" encoding="utf-8"?>
+<p:notes xmlns:p="http://schemas.openxmlformats.org/presentationml/2006/main">
+  <p:cSld>
+    <p:spTree>
+      <p:nvGrpSpPr>
+        <p:cNvPr id="1" name=""/>
+        <p:cNvGrpSpPr/>
+        <p:nvPr/>
+      </p:nvGrpSpPr>
+      <p:grpSpPr>
+        <a:xfrm xmlns:a="http://schemas.openxmlformats.org/drawingml/2006/main"/>
+      </p:grpSpPr>
+      <p:sp>
+        <p:nvSpPr>
+          <p:cNvPr id="2" name="Slide Image Placeholder 1"/>
+          <p:cNvSpPr>
+            <a:spLocks xmlns:a="http://schemas.openxmlformats.org/drawingml/2006/main" noGrp="1"/>
+          </p:cNvSpPr>
+          <p:nvPr>
+            <p:ph type="sldImg" idx="0"/>
+          </p:nvPr>
+        </p:nvSpPr>
+        <p:spPr/>
+      </p:sp>
+      <p:sp>
+        <p:nvSpPr>
+          <p:cNvPr id="3" name="Notes Placeholder 2"/>
+          <p:cNvSpPr>
+            <a:spLocks xmlns:a="http://schemas.openxmlformats.org/drawingml/2006/main" noGrp="1"/>
+          </p:cNvSpPr>
+          <p:nvPr>
+            <p:ph type="body" idx="1"/>
+          </p:nvPr>
+        </p:nvSpPr>
+        <p:spPr/>
+        <p:txBody>
+          <a:bodyPr xmlns:a="http://schemas.openxmlformats.org/drawingml/2006/main"/>
+          <a:lstStyle xmlns:a="http://schemas.openxmlformats.org/drawingml/2006/main"/>
+          <a:p xmlns:a="http://schemas.openxmlformats.org/drawingml/2006/main">
+            <a:r>
               <a:t>Close honestly: code and repeatable local proof are complete; acceptance cannot be claimed until authorized AWS access is restored and the matrix is replayed.</a:t>
             </a:r>
           </a:p>
@@ -1465,7 +1571,7 @@
   </p:cSld>
   <p:clrMap bg1="lt1" tx1="dk1" bg2="lt2" tx2="dk2" accent1="accent1" accent2="accent2" accent3="accent3" accent4="accent4" accent5="accent5" accent6="accent6" hlink="hlink" folHlink="folHlink"/>
   <p:sldLayoutIdLst>
-    <p:sldLayoutId xmlns:r="http://schemas.openxmlformats.org/officeDocument/2006/relationships" id="2147483649" r:id="Re749dd163fce4ffa"/>
+    <p:sldLayoutId xmlns:r="http://schemas.openxmlformats.org/officeDocument/2006/relationships" id="2147483649" r:id="Rd9753d2611a84654"/>
   </p:sldLayoutIdLst>
   <p:txStyles>
     <p:titleStyle>
@@ -2239,6 +2345,7 @@
           <a:lstStyle xmlns:a="http://schemas.openxmlformats.org/drawingml/2006/main"/>
           <a:p xmlns:a="http://schemas.openxmlformats.org/drawingml/2006/main">
             <a:pPr>
+              <a:buNone/>
               <a:defRPr sz="1275" b="1">
                 <a:solidFill>
                   <a:srgbClr val="3D8DFF"/>
@@ -2297,6 +2404,7 @@
           <a:lstStyle xmlns:a="http://schemas.openxmlformats.org/drawingml/2006/main"/>
           <a:p xmlns:a="http://schemas.openxmlformats.org/drawingml/2006/main">
             <a:pPr>
+              <a:buNone/>
               <a:defRPr sz="4800" b="1">
                 <a:solidFill>
                   <a:srgbClr val="101114"/>
@@ -2355,6 +2463,7 @@
           <a:lstStyle xmlns:a="http://schemas.openxmlformats.org/drawingml/2006/main"/>
           <a:p xmlns:a="http://schemas.openxmlformats.org/drawingml/2006/main">
             <a:pPr>
+              <a:buNone/>
               <a:defRPr sz="1875">
                 <a:solidFill>
                   <a:srgbClr val="5F6672"/>
@@ -2378,6 +2487,7 @@
           </a:p>
           <a:p xmlns:a="http://schemas.openxmlformats.org/drawingml/2006/main">
             <a:pPr>
+              <a:buNone/>
               <a:defRPr sz="1875">
                 <a:solidFill>
                   <a:srgbClr val="5F6672"/>
@@ -2403,14 +2513,14 @@
       </p:sp>
       <p:pic>
         <p:nvPicPr>
-          <p:cNvPr id="9" name=""/>
+          <p:cNvPr id="11" name=""/>
           <p:cNvPicPr>
             <a:picLocks xmlns:a="http://schemas.openxmlformats.org/drawingml/2006/main" noChangeAspect="1"/>
           </p:cNvPicPr>
           <p:nvPr/>
         </p:nvPicPr>
         <p:blipFill>
-          <a:blip xmlns:r="http://schemas.openxmlformats.org/officeDocument/2006/relationships" xmlns:a="http://schemas.openxmlformats.org/drawingml/2006/main" r:embed="Rc878fe16dc4d4047"/>
+          <a:blip xmlns:r="http://schemas.openxmlformats.org/officeDocument/2006/relationships" xmlns:a="http://schemas.openxmlformats.org/drawingml/2006/main" r:embed="R6c7469e12c6b457d"/>
           <a:srcRect xmlns:a="http://schemas.openxmlformats.org/drawingml/2006/main" l="21833" t="0" r="21833" b="0"/>
           <a:stretch xmlns:a="http://schemas.openxmlformats.org/drawingml/2006/main">
             <a:fillRect l="0" t="0" r="0" b="0"/>
@@ -2463,6 +2573,7 @@
           <a:lstStyle xmlns:a="http://schemas.openxmlformats.org/drawingml/2006/main"/>
           <a:p xmlns:a="http://schemas.openxmlformats.org/drawingml/2006/main">
             <a:pPr>
+              <a:buNone/>
               <a:defRPr sz="1050">
                 <a:solidFill>
                   <a:srgbClr val="5F6672"/>
@@ -2543,6 +2654,7 @@
           <a:lstStyle xmlns:a="http://schemas.openxmlformats.org/drawingml/2006/main"/>
           <a:p xmlns:a="http://schemas.openxmlformats.org/drawingml/2006/main">
             <a:pPr>
+              <a:buNone/>
               <a:defRPr sz="1125" b="1">
                 <a:solidFill>
                   <a:srgbClr val="3D8DFF"/>
@@ -2601,6 +2713,7 @@
           <a:lstStyle xmlns:a="http://schemas.openxmlformats.org/drawingml/2006/main"/>
           <a:p xmlns:a="http://schemas.openxmlformats.org/drawingml/2006/main">
             <a:pPr>
+              <a:buNone/>
               <a:defRPr sz="3600" b="1">
                 <a:solidFill>
                   <a:srgbClr val="101114"/>
@@ -2659,6 +2772,7 @@
           <a:lstStyle xmlns:a="http://schemas.openxmlformats.org/drawingml/2006/main"/>
           <a:p xmlns:a="http://schemas.openxmlformats.org/drawingml/2006/main">
             <a:pPr algn="r">
+              <a:buNone/>
               <a:defRPr sz="1050">
                 <a:solidFill>
                   <a:srgbClr val="5F6672"/>
@@ -2717,6 +2831,7 @@
           <a:lstStyle xmlns:a="http://schemas.openxmlformats.org/drawingml/2006/main"/>
           <a:p xmlns:a="http://schemas.openxmlformats.org/drawingml/2006/main">
             <a:pPr algn="ctr">
+              <a:buNone/>
               <a:defRPr sz="5400" b="1">
                 <a:solidFill>
                   <a:srgbClr val="101114"/>
@@ -2775,6 +2890,7 @@
           <a:lstStyle xmlns:a="http://schemas.openxmlformats.org/drawingml/2006/main"/>
           <a:p xmlns:a="http://schemas.openxmlformats.org/drawingml/2006/main">
             <a:pPr algn="ctr">
+              <a:buNone/>
               <a:defRPr sz="1650">
                 <a:solidFill>
                   <a:srgbClr val="5F6672"/>
@@ -2833,6 +2949,7 @@
           <a:lstStyle xmlns:a="http://schemas.openxmlformats.org/drawingml/2006/main"/>
           <a:p xmlns:a="http://schemas.openxmlformats.org/drawingml/2006/main">
             <a:pPr algn="ctr">
+              <a:buNone/>
               <a:defRPr sz="5400" b="1">
                 <a:solidFill>
                   <a:srgbClr val="101114"/>
@@ -2891,6 +3008,7 @@
           <a:lstStyle xmlns:a="http://schemas.openxmlformats.org/drawingml/2006/main"/>
           <a:p xmlns:a="http://schemas.openxmlformats.org/drawingml/2006/main">
             <a:pPr algn="ctr">
+              <a:buNone/>
               <a:defRPr sz="1650">
                 <a:solidFill>
                   <a:srgbClr val="5F6672"/>
@@ -2949,6 +3067,7 @@
           <a:lstStyle xmlns:a="http://schemas.openxmlformats.org/drawingml/2006/main"/>
           <a:p xmlns:a="http://schemas.openxmlformats.org/drawingml/2006/main">
             <a:pPr algn="ctr">
+              <a:buNone/>
               <a:defRPr sz="5400" b="1">
                 <a:solidFill>
                   <a:srgbClr val="3D8DFF"/>
@@ -3007,6 +3126,7 @@
           <a:lstStyle xmlns:a="http://schemas.openxmlformats.org/drawingml/2006/main"/>
           <a:p xmlns:a="http://schemas.openxmlformats.org/drawingml/2006/main">
             <a:pPr algn="ctr">
+              <a:buNone/>
               <a:defRPr sz="1650">
                 <a:solidFill>
                   <a:srgbClr val="5F6672"/>
@@ -3065,6 +3185,7 @@
           <a:lstStyle xmlns:a="http://schemas.openxmlformats.org/drawingml/2006/main"/>
           <a:p xmlns:a="http://schemas.openxmlformats.org/drawingml/2006/main">
             <a:pPr algn="ctr">
+              <a:buNone/>
               <a:defRPr sz="5400" b="1">
                 <a:solidFill>
                   <a:srgbClr val="3D8DFF"/>
@@ -3123,6 +3244,7 @@
           <a:lstStyle xmlns:a="http://schemas.openxmlformats.org/drawingml/2006/main"/>
           <a:p xmlns:a="http://schemas.openxmlformats.org/drawingml/2006/main">
             <a:pPr algn="ctr">
+              <a:buNone/>
               <a:defRPr sz="1650">
                 <a:solidFill>
                   <a:srgbClr val="5F6672"/>
@@ -3216,6 +3338,7 @@
           <a:lstStyle xmlns:a="http://schemas.openxmlformats.org/drawingml/2006/main"/>
           <a:p xmlns:a="http://schemas.openxmlformats.org/drawingml/2006/main">
             <a:pPr algn="ctr">
+              <a:buNone/>
               <a:defRPr sz="2025" b="1">
                 <a:solidFill>
                   <a:srgbClr val="0A6B4A"/>
@@ -3263,6 +3386,771 @@
       </p:grpSpPr>
       <p:sp>
         <p:nvSpPr>
+          <p:cNvPr id="14" name="kicker">
+            <a:extLst xmlns:a="http://schemas.openxmlformats.org/drawingml/2006/main">
+              <a:ext uri="{FF2B5EF4-FFF2-40B4-BE49-F238E27FC236}">
+                <a16:creationId xmlns:a16="http://schemas.microsoft.com/office/drawing/2014/main" id="{E8E5B5B6-FE1C-4D0C-B4DC-84740B3A7453}"/>
+              </a:ext>
+            </a:extLst>
+          </p:cNvPr>
+          <p:cNvSpPr>
+            <a:spLocks xmlns:a="http://schemas.openxmlformats.org/drawingml/2006/main" noGrp="1"/>
+          </p:cNvSpPr>
+          <p:nvPr/>
+        </p:nvSpPr>
+        <p:spPr>
+          <a:xfrm xmlns:a="http://schemas.openxmlformats.org/drawingml/2006/main">
+            <a:off x="400050" y="323850"/>
+            <a:ext cx="3048000" cy="285750"/>
+          </a:xfrm>
+          <a:prstGeom xmlns:a="http://schemas.openxmlformats.org/drawingml/2006/main" prst="rect">
+            <a:avLst/>
+          </a:prstGeom>
+          <a:noFill xmlns:a="http://schemas.openxmlformats.org/drawingml/2006/main"/>
+          <a:ln xmlns:a="http://schemas.openxmlformats.org/drawingml/2006/main" w="0">
+            <a:noFill/>
+            <a:prstDash val="solid"/>
+          </a:ln>
+        </p:spPr>
+        <p:txBody>
+          <a:bodyPr xmlns:a="http://schemas.openxmlformats.org/drawingml/2006/main" anchor="t">
+            <a:normAutofit fontScale="100000"/>
+          </a:bodyPr>
+          <a:lstStyle xmlns:a="http://schemas.openxmlformats.org/drawingml/2006/main"/>
+          <a:p xmlns:a="http://schemas.openxmlformats.org/drawingml/2006/main">
+            <a:pPr>
+              <a:buNone/>
+              <a:defRPr sz="1125" b="1">
+                <a:solidFill>
+                  <a:srgbClr val="3D8DFF"/>
+                </a:solidFill>
+                <a:latin typeface="Helvetica Neue"/>
+                <a:ea typeface="Helvetica Neue"/>
+                <a:cs typeface="Helvetica Neue"/>
+              </a:defRPr>
+            </a:pPr>
+            <a:r>
+              <a:rPr sz="1125" b="1">
+                <a:solidFill>
+                  <a:srgbClr val="3D8DFF"/>
+                </a:solidFill>
+                <a:latin typeface="Helvetica Neue"/>
+                <a:ea typeface="Helvetica Neue"/>
+                <a:cs typeface="Helvetica Neue"/>
+              </a:rPr>
+              <a:t>10 · RUBRIC EVIDENCE</a:t>
+            </a:r>
+          </a:p>
+        </p:txBody>
+      </p:sp>
+      <p:sp>
+        <p:nvSpPr>
+          <p:cNvPr id="2" name="slide-title">
+            <a:extLst xmlns:a="http://schemas.openxmlformats.org/drawingml/2006/main">
+              <a:ext uri="{FF2B5EF4-FFF2-40B4-BE49-F238E27FC236}">
+                <a16:creationId xmlns:a16="http://schemas.microsoft.com/office/drawing/2014/main" id="{7BA7BC0A-F757-4B2F-9972-381DFE98F90A}"/>
+              </a:ext>
+            </a:extLst>
+          </p:cNvPr>
+          <p:cNvSpPr>
+            <a:spLocks xmlns:a="http://schemas.openxmlformats.org/drawingml/2006/main" noGrp="1"/>
+          </p:cNvSpPr>
+          <p:nvPr/>
+        </p:nvSpPr>
+        <p:spPr>
+          <a:xfrm xmlns:a="http://schemas.openxmlformats.org/drawingml/2006/main">
+            <a:off x="400050" y="647700"/>
+            <a:ext cx="10858500" cy="1066800"/>
+          </a:xfrm>
+          <a:prstGeom xmlns:a="http://schemas.openxmlformats.org/drawingml/2006/main" prst="rect">
+            <a:avLst/>
+          </a:prstGeom>
+          <a:noFill xmlns:a="http://schemas.openxmlformats.org/drawingml/2006/main"/>
+          <a:ln xmlns:a="http://schemas.openxmlformats.org/drawingml/2006/main" w="0">
+            <a:noFill/>
+            <a:prstDash val="solid"/>
+          </a:ln>
+        </p:spPr>
+        <p:txBody>
+          <a:bodyPr xmlns:a="http://schemas.openxmlformats.org/drawingml/2006/main" anchor="t">
+            <a:normAutofit fontScale="100000"/>
+          </a:bodyPr>
+          <a:lstStyle xmlns:a="http://schemas.openxmlformats.org/drawingml/2006/main"/>
+          <a:p xmlns:a="http://schemas.openxmlformats.org/drawingml/2006/main">
+            <a:pPr>
+              <a:buNone/>
+              <a:defRPr sz="3600" b="1">
+                <a:solidFill>
+                  <a:srgbClr val="101114"/>
+                </a:solidFill>
+                <a:latin typeface="Helvetica Neue"/>
+                <a:ea typeface="Helvetica Neue"/>
+                <a:cs typeface="Helvetica Neue"/>
+              </a:defRPr>
+            </a:pPr>
+            <a:r>
+              <a:rPr sz="3600" b="1">
+                <a:solidFill>
+                  <a:srgbClr val="101114"/>
+                </a:solidFill>
+                <a:latin typeface="Helvetica Neue"/>
+                <a:ea typeface="Helvetica Neue"/>
+                <a:cs typeface="Helvetica Neue"/>
+              </a:rPr>
+              <a:t>Claims are now linked to repeatable evidence</a:t>
+            </a:r>
+          </a:p>
+        </p:txBody>
+      </p:sp>
+      <p:sp>
+        <p:nvSpPr>
+          <p:cNvPr id="3" name="page-number">
+            <a:extLst xmlns:a="http://schemas.openxmlformats.org/drawingml/2006/main">
+              <a:ext uri="{FF2B5EF4-FFF2-40B4-BE49-F238E27FC236}">
+                <a16:creationId xmlns:a16="http://schemas.microsoft.com/office/drawing/2014/main" id="{E3FA7BCC-9745-4E50-99AC-71B82C5B2B1C}"/>
+              </a:ext>
+            </a:extLst>
+          </p:cNvPr>
+          <p:cNvSpPr>
+            <a:spLocks xmlns:a="http://schemas.openxmlformats.org/drawingml/2006/main" noGrp="1"/>
+          </p:cNvSpPr>
+          <p:nvPr/>
+        </p:nvSpPr>
+        <p:spPr>
+          <a:xfrm xmlns:a="http://schemas.openxmlformats.org/drawingml/2006/main">
+            <a:off x="11239500" y="6286500"/>
+            <a:ext cx="533400" cy="228600"/>
+          </a:xfrm>
+          <a:prstGeom xmlns:a="http://schemas.openxmlformats.org/drawingml/2006/main" prst="rect">
+            <a:avLst/>
+          </a:prstGeom>
+          <a:noFill xmlns:a="http://schemas.openxmlformats.org/drawingml/2006/main"/>
+          <a:ln xmlns:a="http://schemas.openxmlformats.org/drawingml/2006/main" w="0">
+            <a:noFill/>
+            <a:prstDash val="solid"/>
+          </a:ln>
+        </p:spPr>
+        <p:txBody>
+          <a:bodyPr xmlns:a="http://schemas.openxmlformats.org/drawingml/2006/main" anchor="t">
+            <a:normAutofit fontScale="85714"/>
+          </a:bodyPr>
+          <a:lstStyle xmlns:a="http://schemas.openxmlformats.org/drawingml/2006/main"/>
+          <a:p xmlns:a="http://schemas.openxmlformats.org/drawingml/2006/main">
+            <a:pPr algn="r">
+              <a:buNone/>
+              <a:defRPr sz="1050">
+                <a:solidFill>
+                  <a:srgbClr val="5F6672"/>
+                </a:solidFill>
+                <a:latin typeface="Helvetica Neue"/>
+                <a:ea typeface="Helvetica Neue"/>
+                <a:cs typeface="Helvetica Neue"/>
+              </a:defRPr>
+            </a:pPr>
+            <a:r>
+              <a:rPr sz="1050">
+                <a:solidFill>
+                  <a:srgbClr val="5F6672"/>
+                </a:solidFill>
+                <a:latin typeface="Helvetica Neue"/>
+                <a:ea typeface="Helvetica Neue"/>
+                <a:cs typeface="Helvetica Neue"/>
+              </a:rPr>
+              <a:t>11</a:t>
+            </a:r>
+          </a:p>
+        </p:txBody>
+      </p:sp>
+      <p:sp>
+        <p:nvSpPr>
+          <p:cNvPr id="4" name="restore-stat-0">
+            <a:extLst xmlns:a="http://schemas.openxmlformats.org/drawingml/2006/main">
+              <a:ext uri="{FF2B5EF4-FFF2-40B4-BE49-F238E27FC236}">
+                <a16:creationId xmlns:a16="http://schemas.microsoft.com/office/drawing/2014/main" id="{61D72115-C293-469B-9594-BBD270F755B4}"/>
+              </a:ext>
+            </a:extLst>
+          </p:cNvPr>
+          <p:cNvSpPr>
+            <a:spLocks xmlns:a="http://schemas.openxmlformats.org/drawingml/2006/main" noGrp="1"/>
+          </p:cNvSpPr>
+          <p:nvPr/>
+        </p:nvSpPr>
+        <p:spPr>
+          <a:xfrm xmlns:a="http://schemas.openxmlformats.org/drawingml/2006/main">
+            <a:off x="495300" y="2000250"/>
+            <a:ext cx="2381250" cy="1047750"/>
+          </a:xfrm>
+          <a:prstGeom xmlns:a="http://schemas.openxmlformats.org/drawingml/2006/main" prst="rect">
+            <a:avLst/>
+          </a:prstGeom>
+          <a:noFill xmlns:a="http://schemas.openxmlformats.org/drawingml/2006/main"/>
+          <a:ln xmlns:a="http://schemas.openxmlformats.org/drawingml/2006/main" w="0">
+            <a:noFill/>
+            <a:prstDash val="solid"/>
+          </a:ln>
+        </p:spPr>
+        <p:txBody>
+          <a:bodyPr xmlns:a="http://schemas.openxmlformats.org/drawingml/2006/main" anchor="t">
+            <a:normAutofit fontScale="100000"/>
+          </a:bodyPr>
+          <a:lstStyle xmlns:a="http://schemas.openxmlformats.org/drawingml/2006/main"/>
+          <a:p xmlns:a="http://schemas.openxmlformats.org/drawingml/2006/main">
+            <a:pPr algn="ctr">
+              <a:buNone/>
+              <a:defRPr sz="5400" b="1">
+                <a:solidFill>
+                  <a:srgbClr val="101114"/>
+                </a:solidFill>
+                <a:latin typeface="Helvetica Neue"/>
+                <a:ea typeface="Helvetica Neue"/>
+                <a:cs typeface="Helvetica Neue"/>
+              </a:defRPr>
+            </a:pPr>
+            <a:r>
+              <a:rPr sz="5400" b="1">
+                <a:solidFill>
+                  <a:srgbClr val="101114"/>
+                </a:solidFill>
+                <a:latin typeface="Helvetica Neue"/>
+                <a:ea typeface="Helvetica Neue"/>
+                <a:cs typeface="Helvetica Neue"/>
+              </a:rPr>
+              <a:t>8/8</a:t>
+            </a:r>
+          </a:p>
+        </p:txBody>
+      </p:sp>
+      <p:sp>
+        <p:nvSpPr>
+          <p:cNvPr id="5" name="restore-label-0">
+            <a:extLst xmlns:a="http://schemas.openxmlformats.org/drawingml/2006/main">
+              <a:ext uri="{FF2B5EF4-FFF2-40B4-BE49-F238E27FC236}">
+                <a16:creationId xmlns:a16="http://schemas.microsoft.com/office/drawing/2014/main" id="{5C1047A0-4637-4024-8B8A-0A7F0A2583DE}"/>
+              </a:ext>
+            </a:extLst>
+          </p:cNvPr>
+          <p:cNvSpPr>
+            <a:spLocks xmlns:a="http://schemas.openxmlformats.org/drawingml/2006/main" noGrp="1"/>
+          </p:cNvSpPr>
+          <p:nvPr/>
+        </p:nvSpPr>
+        <p:spPr>
+          <a:xfrm xmlns:a="http://schemas.openxmlformats.org/drawingml/2006/main">
+            <a:off x="495300" y="3105150"/>
+            <a:ext cx="2381250" cy="400050"/>
+          </a:xfrm>
+          <a:prstGeom xmlns:a="http://schemas.openxmlformats.org/drawingml/2006/main" prst="rect">
+            <a:avLst/>
+          </a:prstGeom>
+          <a:noFill xmlns:a="http://schemas.openxmlformats.org/drawingml/2006/main"/>
+          <a:ln xmlns:a="http://schemas.openxmlformats.org/drawingml/2006/main" w="0">
+            <a:noFill/>
+            <a:prstDash val="solid"/>
+          </a:ln>
+        </p:spPr>
+        <p:txBody>
+          <a:bodyPr xmlns:a="http://schemas.openxmlformats.org/drawingml/2006/main" anchor="t">
+            <a:normAutofit fontScale="100000"/>
+          </a:bodyPr>
+          <a:lstStyle xmlns:a="http://schemas.openxmlformats.org/drawingml/2006/main"/>
+          <a:p xmlns:a="http://schemas.openxmlformats.org/drawingml/2006/main">
+            <a:pPr algn="ctr">
+              <a:buNone/>
+              <a:defRPr sz="1650">
+                <a:solidFill>
+                  <a:srgbClr val="5F6672"/>
+                </a:solidFill>
+                <a:latin typeface="Helvetica Neue"/>
+                <a:ea typeface="Helvetica Neue"/>
+                <a:cs typeface="Helvetica Neue"/>
+              </a:defRPr>
+            </a:pPr>
+            <a:r>
+              <a:rPr sz="1650">
+                <a:solidFill>
+                  <a:srgbClr val="5F6672"/>
+                </a:solidFill>
+                <a:latin typeface="Helvetica Neue"/>
+                <a:ea typeface="Helvetica Neue"/>
+                <a:cs typeface="Helvetica Neue"/>
+              </a:rPr>
+              <a:t>business requirements</a:t>
+            </a:r>
+          </a:p>
+        </p:txBody>
+      </p:sp>
+      <p:sp>
+        <p:nvSpPr>
+          <p:cNvPr id="6" name="restore-stat-1">
+            <a:extLst xmlns:a="http://schemas.openxmlformats.org/drawingml/2006/main">
+              <a:ext uri="{FF2B5EF4-FFF2-40B4-BE49-F238E27FC236}">
+                <a16:creationId xmlns:a16="http://schemas.microsoft.com/office/drawing/2014/main" id="{56354A97-C20E-497A-BA05-51F55E76B534}"/>
+              </a:ext>
+            </a:extLst>
+          </p:cNvPr>
+          <p:cNvSpPr>
+            <a:spLocks xmlns:a="http://schemas.openxmlformats.org/drawingml/2006/main" noGrp="1"/>
+          </p:cNvSpPr>
+          <p:nvPr/>
+        </p:nvSpPr>
+        <p:spPr>
+          <a:xfrm xmlns:a="http://schemas.openxmlformats.org/drawingml/2006/main">
+            <a:off x="3390900" y="2000250"/>
+            <a:ext cx="2381250" cy="1047750"/>
+          </a:xfrm>
+          <a:prstGeom xmlns:a="http://schemas.openxmlformats.org/drawingml/2006/main" prst="rect">
+            <a:avLst/>
+          </a:prstGeom>
+          <a:noFill xmlns:a="http://schemas.openxmlformats.org/drawingml/2006/main"/>
+          <a:ln xmlns:a="http://schemas.openxmlformats.org/drawingml/2006/main" w="0">
+            <a:noFill/>
+            <a:prstDash val="solid"/>
+          </a:ln>
+        </p:spPr>
+        <p:txBody>
+          <a:bodyPr xmlns:a="http://schemas.openxmlformats.org/drawingml/2006/main" anchor="t">
+            <a:normAutofit fontScale="100000"/>
+          </a:bodyPr>
+          <a:lstStyle xmlns:a="http://schemas.openxmlformats.org/drawingml/2006/main"/>
+          <a:p xmlns:a="http://schemas.openxmlformats.org/drawingml/2006/main">
+            <a:pPr algn="ctr">
+              <a:buNone/>
+              <a:defRPr sz="5400" b="1">
+                <a:solidFill>
+                  <a:srgbClr val="101114"/>
+                </a:solidFill>
+                <a:latin typeface="Helvetica Neue"/>
+                <a:ea typeface="Helvetica Neue"/>
+                <a:cs typeface="Helvetica Neue"/>
+              </a:defRPr>
+            </a:pPr>
+            <a:r>
+              <a:rPr sz="5400" b="1">
+                <a:solidFill>
+                  <a:srgbClr val="101114"/>
+                </a:solidFill>
+                <a:latin typeface="Helvetica Neue"/>
+                <a:ea typeface="Helvetica Neue"/>
+                <a:cs typeface="Helvetica Neue"/>
+              </a:rPr>
+              <a:t>4/4</a:t>
+            </a:r>
+          </a:p>
+        </p:txBody>
+      </p:sp>
+      <p:sp>
+        <p:nvSpPr>
+          <p:cNvPr id="7" name="restore-label-1">
+            <a:extLst xmlns:a="http://schemas.openxmlformats.org/drawingml/2006/main">
+              <a:ext uri="{FF2B5EF4-FFF2-40B4-BE49-F238E27FC236}">
+                <a16:creationId xmlns:a16="http://schemas.microsoft.com/office/drawing/2014/main" id="{D1526BD5-3445-4EFA-89A8-6D472BDAD58C}"/>
+              </a:ext>
+            </a:extLst>
+          </p:cNvPr>
+          <p:cNvSpPr>
+            <a:spLocks xmlns:a="http://schemas.openxmlformats.org/drawingml/2006/main" noGrp="1"/>
+          </p:cNvSpPr>
+          <p:nvPr/>
+        </p:nvSpPr>
+        <p:spPr>
+          <a:xfrm xmlns:a="http://schemas.openxmlformats.org/drawingml/2006/main">
+            <a:off x="3390900" y="3105150"/>
+            <a:ext cx="2381250" cy="400050"/>
+          </a:xfrm>
+          <a:prstGeom xmlns:a="http://schemas.openxmlformats.org/drawingml/2006/main" prst="rect">
+            <a:avLst/>
+          </a:prstGeom>
+          <a:noFill xmlns:a="http://schemas.openxmlformats.org/drawingml/2006/main"/>
+          <a:ln xmlns:a="http://schemas.openxmlformats.org/drawingml/2006/main" w="0">
+            <a:noFill/>
+            <a:prstDash val="solid"/>
+          </a:ln>
+        </p:spPr>
+        <p:txBody>
+          <a:bodyPr xmlns:a="http://schemas.openxmlformats.org/drawingml/2006/main" anchor="t">
+            <a:normAutofit fontScale="100000"/>
+          </a:bodyPr>
+          <a:lstStyle xmlns:a="http://schemas.openxmlformats.org/drawingml/2006/main"/>
+          <a:p xmlns:a="http://schemas.openxmlformats.org/drawingml/2006/main">
+            <a:pPr algn="ctr">
+              <a:buNone/>
+              <a:defRPr sz="1650">
+                <a:solidFill>
+                  <a:srgbClr val="5F6672"/>
+                </a:solidFill>
+                <a:latin typeface="Helvetica Neue"/>
+                <a:ea typeface="Helvetica Neue"/>
+                <a:cs typeface="Helvetica Neue"/>
+              </a:defRPr>
+            </a:pPr>
+            <a:r>
+              <a:rPr sz="1650">
+                <a:solidFill>
+                  <a:srgbClr val="5F6672"/>
+                </a:solidFill>
+                <a:latin typeface="Helvetica Neue"/>
+                <a:ea typeface="Helvetica Neue"/>
+                <a:cs typeface="Helvetica Neue"/>
+              </a:rPr>
+              <a:t>offline screening stations</a:t>
+            </a:r>
+          </a:p>
+        </p:txBody>
+      </p:sp>
+      <p:sp>
+        <p:nvSpPr>
+          <p:cNvPr id="8" name="restore-stat-2">
+            <a:extLst xmlns:a="http://schemas.openxmlformats.org/drawingml/2006/main">
+              <a:ext uri="{FF2B5EF4-FFF2-40B4-BE49-F238E27FC236}">
+                <a16:creationId xmlns:a16="http://schemas.microsoft.com/office/drawing/2014/main" id="{ADCD0F0D-5A1E-4085-9765-599AD60E0065}"/>
+              </a:ext>
+            </a:extLst>
+          </p:cNvPr>
+          <p:cNvSpPr>
+            <a:spLocks xmlns:a="http://schemas.openxmlformats.org/drawingml/2006/main" noGrp="1"/>
+          </p:cNvSpPr>
+          <p:nvPr/>
+        </p:nvSpPr>
+        <p:spPr>
+          <a:xfrm xmlns:a="http://schemas.openxmlformats.org/drawingml/2006/main">
+            <a:off x="6286500" y="2000250"/>
+            <a:ext cx="2381250" cy="1047750"/>
+          </a:xfrm>
+          <a:prstGeom xmlns:a="http://schemas.openxmlformats.org/drawingml/2006/main" prst="rect">
+            <a:avLst/>
+          </a:prstGeom>
+          <a:noFill xmlns:a="http://schemas.openxmlformats.org/drawingml/2006/main"/>
+          <a:ln xmlns:a="http://schemas.openxmlformats.org/drawingml/2006/main" w="0">
+            <a:noFill/>
+            <a:prstDash val="solid"/>
+          </a:ln>
+        </p:spPr>
+        <p:txBody>
+          <a:bodyPr xmlns:a="http://schemas.openxmlformats.org/drawingml/2006/main" anchor="t">
+            <a:normAutofit fontScale="100000"/>
+          </a:bodyPr>
+          <a:lstStyle xmlns:a="http://schemas.openxmlformats.org/drawingml/2006/main"/>
+          <a:p xmlns:a="http://schemas.openxmlformats.org/drawingml/2006/main">
+            <a:pPr algn="ctr">
+              <a:buNone/>
+              <a:defRPr sz="5400" b="1">
+                <a:solidFill>
+                  <a:srgbClr val="3D8DFF"/>
+                </a:solidFill>
+                <a:latin typeface="Helvetica Neue"/>
+                <a:ea typeface="Helvetica Neue"/>
+                <a:cs typeface="Helvetica Neue"/>
+              </a:defRPr>
+            </a:pPr>
+            <a:r>
+              <a:rPr sz="5400" b="1">
+                <a:solidFill>
+                  <a:srgbClr val="3D8DFF"/>
+                </a:solidFill>
+                <a:latin typeface="Helvetica Neue"/>
+                <a:ea typeface="Helvetica Neue"/>
+                <a:cs typeface="Helvetica Neue"/>
+              </a:rPr>
+              <a:t>10</a:t>
+            </a:r>
+          </a:p>
+        </p:txBody>
+      </p:sp>
+      <p:sp>
+        <p:nvSpPr>
+          <p:cNvPr id="9" name="restore-label-2">
+            <a:extLst xmlns:a="http://schemas.openxmlformats.org/drawingml/2006/main">
+              <a:ext uri="{FF2B5EF4-FFF2-40B4-BE49-F238E27FC236}">
+                <a16:creationId xmlns:a16="http://schemas.microsoft.com/office/drawing/2014/main" id="{4FCBCDCE-ADD3-4B3B-9E0E-E32E908E4ADD}"/>
+              </a:ext>
+            </a:extLst>
+          </p:cNvPr>
+          <p:cNvSpPr>
+            <a:spLocks xmlns:a="http://schemas.openxmlformats.org/drawingml/2006/main" noGrp="1"/>
+          </p:cNvSpPr>
+          <p:nvPr/>
+        </p:nvSpPr>
+        <p:spPr>
+          <a:xfrm xmlns:a="http://schemas.openxmlformats.org/drawingml/2006/main">
+            <a:off x="6286500" y="3105150"/>
+            <a:ext cx="2381250" cy="400050"/>
+          </a:xfrm>
+          <a:prstGeom xmlns:a="http://schemas.openxmlformats.org/drawingml/2006/main" prst="rect">
+            <a:avLst/>
+          </a:prstGeom>
+          <a:noFill xmlns:a="http://schemas.openxmlformats.org/drawingml/2006/main"/>
+          <a:ln xmlns:a="http://schemas.openxmlformats.org/drawingml/2006/main" w="0">
+            <a:noFill/>
+            <a:prstDash val="solid"/>
+          </a:ln>
+        </p:spPr>
+        <p:txBody>
+          <a:bodyPr xmlns:a="http://schemas.openxmlformats.org/drawingml/2006/main" anchor="t">
+            <a:normAutofit fontScale="95157"/>
+          </a:bodyPr>
+          <a:lstStyle xmlns:a="http://schemas.openxmlformats.org/drawingml/2006/main"/>
+          <a:p xmlns:a="http://schemas.openxmlformats.org/drawingml/2006/main">
+            <a:pPr algn="ctr">
+              <a:buNone/>
+              <a:defRPr sz="1650">
+                <a:solidFill>
+                  <a:srgbClr val="5F6672"/>
+                </a:solidFill>
+                <a:latin typeface="Helvetica Neue"/>
+                <a:ea typeface="Helvetica Neue"/>
+                <a:cs typeface="Helvetica Neue"/>
+              </a:defRPr>
+            </a:pPr>
+            <a:r>
+              <a:rPr sz="1650">
+                <a:solidFill>
+                  <a:srgbClr val="5F6672"/>
+                </a:solidFill>
+                <a:latin typeface="Helvetica Neue"/>
+                <a:ea typeface="Helvetica Neue"/>
+                <a:cs typeface="Helvetica Neue"/>
+              </a:rPr>
+              <a:t>OWASP categories mapped</a:t>
+            </a:r>
+          </a:p>
+        </p:txBody>
+      </p:sp>
+      <p:sp>
+        <p:nvSpPr>
+          <p:cNvPr id="10" name="restore-stat-3">
+            <a:extLst xmlns:a="http://schemas.openxmlformats.org/drawingml/2006/main">
+              <a:ext uri="{FF2B5EF4-FFF2-40B4-BE49-F238E27FC236}">
+                <a16:creationId xmlns:a16="http://schemas.microsoft.com/office/drawing/2014/main" id="{29B88940-0124-4A43-98EF-4F7AA4EE829B}"/>
+              </a:ext>
+            </a:extLst>
+          </p:cNvPr>
+          <p:cNvSpPr>
+            <a:spLocks xmlns:a="http://schemas.openxmlformats.org/drawingml/2006/main" noGrp="1"/>
+          </p:cNvSpPr>
+          <p:nvPr/>
+        </p:nvSpPr>
+        <p:spPr>
+          <a:xfrm xmlns:a="http://schemas.openxmlformats.org/drawingml/2006/main">
+            <a:off x="9182100" y="2000250"/>
+            <a:ext cx="2381250" cy="1047750"/>
+          </a:xfrm>
+          <a:prstGeom xmlns:a="http://schemas.openxmlformats.org/drawingml/2006/main" prst="rect">
+            <a:avLst/>
+          </a:prstGeom>
+          <a:noFill xmlns:a="http://schemas.openxmlformats.org/drawingml/2006/main"/>
+          <a:ln xmlns:a="http://schemas.openxmlformats.org/drawingml/2006/main" w="0">
+            <a:noFill/>
+            <a:prstDash val="solid"/>
+          </a:ln>
+        </p:spPr>
+        <p:txBody>
+          <a:bodyPr xmlns:a="http://schemas.openxmlformats.org/drawingml/2006/main" anchor="t">
+            <a:normAutofit fontScale="100000"/>
+          </a:bodyPr>
+          <a:lstStyle xmlns:a="http://schemas.openxmlformats.org/drawingml/2006/main"/>
+          <a:p xmlns:a="http://schemas.openxmlformats.org/drawingml/2006/main">
+            <a:pPr algn="ctr">
+              <a:buNone/>
+              <a:defRPr sz="5400" b="1">
+                <a:solidFill>
+                  <a:srgbClr val="3D8DFF"/>
+                </a:solidFill>
+                <a:latin typeface="Helvetica Neue"/>
+                <a:ea typeface="Helvetica Neue"/>
+                <a:cs typeface="Helvetica Neue"/>
+              </a:defRPr>
+            </a:pPr>
+            <a:r>
+              <a:rPr sz="5400" b="1">
+                <a:solidFill>
+                  <a:srgbClr val="3D8DFF"/>
+                </a:solidFill>
+                <a:latin typeface="Helvetica Neue"/>
+                <a:ea typeface="Helvetica Neue"/>
+                <a:cs typeface="Helvetica Neue"/>
+              </a:rPr>
+              <a:t>427</a:t>
+            </a:r>
+          </a:p>
+        </p:txBody>
+      </p:sp>
+      <p:sp>
+        <p:nvSpPr>
+          <p:cNvPr id="11" name="restore-label-3">
+            <a:extLst xmlns:a="http://schemas.openxmlformats.org/drawingml/2006/main">
+              <a:ext uri="{FF2B5EF4-FFF2-40B4-BE49-F238E27FC236}">
+                <a16:creationId xmlns:a16="http://schemas.microsoft.com/office/drawing/2014/main" id="{739D0637-3B03-45D4-B2BE-5617BEC690B7}"/>
+              </a:ext>
+            </a:extLst>
+          </p:cNvPr>
+          <p:cNvSpPr>
+            <a:spLocks xmlns:a="http://schemas.openxmlformats.org/drawingml/2006/main" noGrp="1"/>
+          </p:cNvSpPr>
+          <p:nvPr/>
+        </p:nvSpPr>
+        <p:spPr>
+          <a:xfrm xmlns:a="http://schemas.openxmlformats.org/drawingml/2006/main">
+            <a:off x="9182100" y="3105150"/>
+            <a:ext cx="2381250" cy="400050"/>
+          </a:xfrm>
+          <a:prstGeom xmlns:a="http://schemas.openxmlformats.org/drawingml/2006/main" prst="rect">
+            <a:avLst/>
+          </a:prstGeom>
+          <a:noFill xmlns:a="http://schemas.openxmlformats.org/drawingml/2006/main"/>
+          <a:ln xmlns:a="http://schemas.openxmlformats.org/drawingml/2006/main" w="0">
+            <a:noFill/>
+            <a:prstDash val="solid"/>
+          </a:ln>
+        </p:spPr>
+        <p:txBody>
+          <a:bodyPr xmlns:a="http://schemas.openxmlformats.org/drawingml/2006/main" anchor="t">
+            <a:normAutofit fontScale="100000"/>
+          </a:bodyPr>
+          <a:lstStyle xmlns:a="http://schemas.openxmlformats.org/drawingml/2006/main"/>
+          <a:p xmlns:a="http://schemas.openxmlformats.org/drawingml/2006/main">
+            <a:pPr algn="ctr">
+              <a:buNone/>
+              <a:defRPr sz="1650">
+                <a:solidFill>
+                  <a:srgbClr val="5F6672"/>
+                </a:solidFill>
+                <a:latin typeface="Helvetica Neue"/>
+                <a:ea typeface="Helvetica Neue"/>
+                <a:cs typeface="Helvetica Neue"/>
+              </a:defRPr>
+            </a:pPr>
+            <a:r>
+              <a:rPr sz="1650">
+                <a:solidFill>
+                  <a:srgbClr val="5F6672"/>
+                </a:solidFill>
+                <a:latin typeface="Helvetica Neue"/>
+                <a:ea typeface="Helvetica Neue"/>
+                <a:cs typeface="Helvetica Neue"/>
+              </a:rPr>
+              <a:t>backend tests passed</a:t>
+            </a:r>
+          </a:p>
+        </p:txBody>
+      </p:sp>
+      <p:sp>
+        <p:nvSpPr>
+          <p:cNvPr id="12" name="restore-proof">
+            <a:extLst xmlns:a="http://schemas.openxmlformats.org/drawingml/2006/main">
+              <a:ext uri="{FF2B5EF4-FFF2-40B4-BE49-F238E27FC236}">
+                <a16:creationId xmlns:a16="http://schemas.microsoft.com/office/drawing/2014/main" id="{9539CE18-E599-4751-9245-F9B9C81DCFC6}"/>
+              </a:ext>
+            </a:extLst>
+          </p:cNvPr>
+          <p:cNvSpPr>
+            <a:spLocks xmlns:a="http://schemas.openxmlformats.org/drawingml/2006/main" noGrp="1"/>
+          </p:cNvSpPr>
+          <p:nvPr/>
+        </p:nvSpPr>
+        <p:spPr>
+          <a:xfrm xmlns:a="http://schemas.openxmlformats.org/drawingml/2006/main">
+            <a:off x="1314450" y="4171950"/>
+            <a:ext cx="9563100" cy="1104900"/>
+          </a:xfrm>
+          <a:prstGeom xmlns:a="http://schemas.openxmlformats.org/drawingml/2006/main" prst="roundRect">
+            <a:avLst>
+              <a:gd name="adj" fmla="val 10345"/>
+            </a:avLst>
+          </a:prstGeom>
+          <a:solidFill xmlns:a="http://schemas.openxmlformats.org/drawingml/2006/main">
+            <a:srgbClr val="EAF7F2"/>
+          </a:solidFill>
+          <a:ln xmlns:a="http://schemas.openxmlformats.org/drawingml/2006/main" w="9525">
+            <a:solidFill>
+              <a:srgbClr val="14966A"/>
+            </a:solidFill>
+            <a:prstDash val="solid"/>
+          </a:ln>
+        </p:spPr>
+      </p:sp>
+      <p:sp>
+        <p:nvSpPr>
+          <p:cNvPr id="13" name="restore-proof-text">
+            <a:extLst xmlns:a="http://schemas.openxmlformats.org/drawingml/2006/main">
+              <a:ext uri="{FF2B5EF4-FFF2-40B4-BE49-F238E27FC236}">
+                <a16:creationId xmlns:a16="http://schemas.microsoft.com/office/drawing/2014/main" id="{177C3EA7-7196-4C4D-930C-FCE48CFBF573}"/>
+              </a:ext>
+            </a:extLst>
+          </p:cNvPr>
+          <p:cNvSpPr>
+            <a:spLocks xmlns:a="http://schemas.openxmlformats.org/drawingml/2006/main" noGrp="1"/>
+          </p:cNvSpPr>
+          <p:nvPr/>
+        </p:nvSpPr>
+        <p:spPr>
+          <a:xfrm xmlns:a="http://schemas.openxmlformats.org/drawingml/2006/main">
+            <a:off x="1733550" y="4457700"/>
+            <a:ext cx="8724900" cy="571500"/>
+          </a:xfrm>
+          <a:prstGeom xmlns:a="http://schemas.openxmlformats.org/drawingml/2006/main" prst="rect">
+            <a:avLst/>
+          </a:prstGeom>
+          <a:noFill xmlns:a="http://schemas.openxmlformats.org/drawingml/2006/main"/>
+          <a:ln xmlns:a="http://schemas.openxmlformats.org/drawingml/2006/main" w="0">
+            <a:noFill/>
+            <a:prstDash val="solid"/>
+          </a:ln>
+        </p:spPr>
+        <p:txBody>
+          <a:bodyPr xmlns:a="http://schemas.openxmlformats.org/drawingml/2006/main" anchor="t">
+            <a:normAutofit fontScale="77778"/>
+          </a:bodyPr>
+          <a:lstStyle xmlns:a="http://schemas.openxmlformats.org/drawingml/2006/main"/>
+          <a:p xmlns:a="http://schemas.openxmlformats.org/drawingml/2006/main">
+            <a:pPr algn="ctr">
+              <a:buNone/>
+              <a:defRPr sz="2025" b="1">
+                <a:solidFill>
+                  <a:srgbClr val="0A6B4A"/>
+                </a:solidFill>
+                <a:latin typeface="Helvetica Neue"/>
+                <a:ea typeface="Helvetica Neue"/>
+                <a:cs typeface="Helvetica Neue"/>
+              </a:defRPr>
+            </a:pPr>
+            <a:r>
+              <a:rPr sz="2025" b="1">
+                <a:solidFill>
+                  <a:srgbClr val="0A6B4A"/>
+                </a:solidFill>
+                <a:latin typeface="Helvetica Neue"/>
+                <a:ea typeface="Helvetica Neue"/>
+                <a:cs typeface="Helvetica Neue"/>
+              </a:rPr>
+              <a:t>Targets remain targets until measured; repository evidence is checked automatically before submission.</a:t>
+            </a:r>
+          </a:p>
+        </p:txBody>
+      </p:sp>
+    </p:spTree>
+    <p:extLst>
+      <p:ext uri="{BB962C8B-B14F-4D97-AF65-F5344CB8AC3E}">
+        <p14:creationId xmlns:p14="http://schemas.microsoft.com/office/powerpoint/2010/main" val="1431634370"/>
+      </p:ext>
+    </p:extLst>
+  </p:cSld>
+</p:sld>
+</file>
+
+<file path=ppt/slides/slide12.xml><?xml version="1.0" encoding="utf-8"?>
+<p:sld xmlns:p="http://schemas.openxmlformats.org/presentationml/2006/main">
+  <p:cSld>
+    <p:spTree>
+      <p:nvGrpSpPr>
+        <p:cNvPr id="1" name=""/>
+        <p:cNvGrpSpPr/>
+        <p:nvPr/>
+      </p:nvGrpSpPr>
+      <p:grpSpPr>
+        <a:xfrm xmlns:a="http://schemas.openxmlformats.org/drawingml/2006/main"/>
+      </p:grpSpPr>
+      <p:sp>
+        <p:nvSpPr>
           <p:cNvPr id="7" name="close-kicker">
             <a:extLst xmlns:a="http://schemas.openxmlformats.org/drawingml/2006/main">
               <a:ext uri="{FF2B5EF4-FFF2-40B4-BE49-F238E27FC236}">
@@ -3296,6 +4184,7 @@
           <a:lstStyle xmlns:a="http://schemas.openxmlformats.org/drawingml/2006/main"/>
           <a:p xmlns:a="http://schemas.openxmlformats.org/drawingml/2006/main">
             <a:pPr>
+              <a:buNone/>
               <a:defRPr sz="1275" b="1">
                 <a:solidFill>
                   <a:srgbClr val="3D8DFF"/>
@@ -3354,6 +4243,7 @@
           <a:lstStyle xmlns:a="http://schemas.openxmlformats.org/drawingml/2006/main"/>
           <a:p xmlns:a="http://schemas.openxmlformats.org/drawingml/2006/main">
             <a:pPr>
+              <a:buNone/>
               <a:defRPr sz="4350" b="1">
                 <a:solidFill>
                   <a:srgbClr val="101114"/>
@@ -3377,6 +4267,7 @@
           </a:p>
           <a:p xmlns:a="http://schemas.openxmlformats.org/drawingml/2006/main">
             <a:pPr>
+              <a:buNone/>
               <a:defRPr sz="4350" b="1">
                 <a:solidFill>
                   <a:srgbClr val="101114"/>
@@ -3435,6 +4326,7 @@
           <a:lstStyle xmlns:a="http://schemas.openxmlformats.org/drawingml/2006/main"/>
           <a:p xmlns:a="http://schemas.openxmlformats.org/drawingml/2006/main">
             <a:pPr>
+              <a:buNone/>
               <a:defRPr sz="2025" b="1">
                 <a:solidFill>
                   <a:srgbClr val="14966A"/>
@@ -3493,6 +4385,7 @@
           <a:lstStyle xmlns:a="http://schemas.openxmlformats.org/drawingml/2006/main"/>
           <a:p xmlns:a="http://schemas.openxmlformats.org/drawingml/2006/main">
             <a:pPr>
+              <a:buNone/>
               <a:defRPr sz="1725">
                 <a:solidFill>
                   <a:srgbClr val="5F6672"/>
@@ -3551,6 +4444,7 @@
           <a:lstStyle xmlns:a="http://schemas.openxmlformats.org/drawingml/2006/main"/>
           <a:p xmlns:a="http://schemas.openxmlformats.org/drawingml/2006/main">
             <a:pPr>
+              <a:buNone/>
               <a:defRPr sz="2025" b="1">
                 <a:solidFill>
                   <a:srgbClr val="B42318"/>
@@ -3609,6 +4503,7 @@
           <a:lstStyle xmlns:a="http://schemas.openxmlformats.org/drawingml/2006/main"/>
           <a:p xmlns:a="http://schemas.openxmlformats.org/drawingml/2006/main">
             <a:pPr>
+              <a:buNone/>
               <a:defRPr sz="1650">
                 <a:solidFill>
                   <a:srgbClr val="5F6672"/>
@@ -3689,6 +4584,7 @@
           <a:lstStyle xmlns:a="http://schemas.openxmlformats.org/drawingml/2006/main"/>
           <a:p xmlns:a="http://schemas.openxmlformats.org/drawingml/2006/main">
             <a:pPr>
+              <a:buNone/>
               <a:defRPr sz="1125" b="1">
                 <a:solidFill>
                   <a:srgbClr val="3D8DFF"/>
@@ -3747,6 +4643,7 @@
           <a:lstStyle xmlns:a="http://schemas.openxmlformats.org/drawingml/2006/main"/>
           <a:p xmlns:a="http://schemas.openxmlformats.org/drawingml/2006/main">
             <a:pPr>
+              <a:buNone/>
               <a:defRPr sz="3600" b="1">
                 <a:solidFill>
                   <a:srgbClr val="101114"/>
@@ -3805,6 +4702,7 @@
           <a:lstStyle xmlns:a="http://schemas.openxmlformats.org/drawingml/2006/main"/>
           <a:p xmlns:a="http://schemas.openxmlformats.org/drawingml/2006/main">
             <a:pPr algn="r">
+              <a:buNone/>
               <a:defRPr sz="1050">
                 <a:solidFill>
                   <a:srgbClr val="5F6672"/>
@@ -4115,6 +5013,7 @@
           <a:lstStyle xmlns:a="http://schemas.openxmlformats.org/drawingml/2006/main"/>
           <a:p xmlns:a="http://schemas.openxmlformats.org/drawingml/2006/main">
             <a:pPr algn="ctr">
+              <a:buNone/>
               <a:defRPr sz="2100" b="1">
                 <a:solidFill>
                   <a:srgbClr val="101114"/>
@@ -4173,6 +5072,7 @@
           <a:lstStyle xmlns:a="http://schemas.openxmlformats.org/drawingml/2006/main"/>
           <a:p xmlns:a="http://schemas.openxmlformats.org/drawingml/2006/main">
             <a:pPr algn="ctr">
+              <a:buNone/>
               <a:defRPr sz="1200" b="1">
                 <a:solidFill>
                   <a:srgbClr val="101114"/>
@@ -4266,6 +5166,7 @@
           <a:lstStyle xmlns:a="http://schemas.openxmlformats.org/drawingml/2006/main"/>
           <a:p xmlns:a="http://schemas.openxmlformats.org/drawingml/2006/main">
             <a:pPr algn="ctr">
+              <a:buNone/>
               <a:defRPr sz="2100" b="1">
                 <a:solidFill>
                   <a:srgbClr val="101114"/>
@@ -4324,6 +5225,7 @@
           <a:lstStyle xmlns:a="http://schemas.openxmlformats.org/drawingml/2006/main"/>
           <a:p xmlns:a="http://schemas.openxmlformats.org/drawingml/2006/main">
             <a:pPr algn="ctr">
+              <a:buNone/>
               <a:defRPr sz="1200" b="1">
                 <a:solidFill>
                   <a:srgbClr val="101114"/>
@@ -4417,6 +5319,7 @@
           <a:lstStyle xmlns:a="http://schemas.openxmlformats.org/drawingml/2006/main"/>
           <a:p xmlns:a="http://schemas.openxmlformats.org/drawingml/2006/main">
             <a:pPr algn="ctr">
+              <a:buNone/>
               <a:defRPr sz="2100" b="1">
                 <a:solidFill>
                   <a:srgbClr val="101114"/>
@@ -4475,6 +5378,7 @@
           <a:lstStyle xmlns:a="http://schemas.openxmlformats.org/drawingml/2006/main"/>
           <a:p xmlns:a="http://schemas.openxmlformats.org/drawingml/2006/main">
             <a:pPr algn="ctr">
+              <a:buNone/>
               <a:defRPr sz="1200" b="1">
                 <a:solidFill>
                   <a:srgbClr val="101114"/>
@@ -4568,6 +5472,7 @@
           <a:lstStyle xmlns:a="http://schemas.openxmlformats.org/drawingml/2006/main"/>
           <a:p xmlns:a="http://schemas.openxmlformats.org/drawingml/2006/main">
             <a:pPr algn="ctr">
+              <a:buNone/>
               <a:defRPr sz="2100" b="1">
                 <a:solidFill>
                   <a:srgbClr val="101114"/>
@@ -4626,6 +5531,7 @@
           <a:lstStyle xmlns:a="http://schemas.openxmlformats.org/drawingml/2006/main"/>
           <a:p xmlns:a="http://schemas.openxmlformats.org/drawingml/2006/main">
             <a:pPr algn="ctr">
+              <a:buNone/>
               <a:defRPr sz="1200" b="1">
                 <a:solidFill>
                   <a:srgbClr val="101114"/>
@@ -4719,6 +5625,7 @@
           <a:lstStyle xmlns:a="http://schemas.openxmlformats.org/drawingml/2006/main"/>
           <a:p xmlns:a="http://schemas.openxmlformats.org/drawingml/2006/main">
             <a:pPr algn="ctr">
+              <a:buNone/>
               <a:defRPr sz="2100" b="1">
                 <a:solidFill>
                   <a:srgbClr val="3D8DFF"/>
@@ -4777,6 +5684,7 @@
           <a:lstStyle xmlns:a="http://schemas.openxmlformats.org/drawingml/2006/main"/>
           <a:p xmlns:a="http://schemas.openxmlformats.org/drawingml/2006/main">
             <a:pPr algn="ctr">
+              <a:buNone/>
               <a:defRPr sz="1200" b="1">
                 <a:solidFill>
                   <a:srgbClr val="101114"/>
@@ -4870,6 +5778,7 @@
           <a:lstStyle xmlns:a="http://schemas.openxmlformats.org/drawingml/2006/main"/>
           <a:p xmlns:a="http://schemas.openxmlformats.org/drawingml/2006/main">
             <a:pPr algn="ctr">
+              <a:buNone/>
               <a:defRPr sz="2100" b="1">
                 <a:solidFill>
                   <a:srgbClr val="101114"/>
@@ -4928,6 +5837,7 @@
           <a:lstStyle xmlns:a="http://schemas.openxmlformats.org/drawingml/2006/main"/>
           <a:p xmlns:a="http://schemas.openxmlformats.org/drawingml/2006/main">
             <a:pPr algn="ctr">
+              <a:buNone/>
               <a:defRPr sz="1200" b="1">
                 <a:solidFill>
                   <a:srgbClr val="101114"/>
@@ -5021,6 +5931,7 @@
           <a:lstStyle xmlns:a="http://schemas.openxmlformats.org/drawingml/2006/main"/>
           <a:p xmlns:a="http://schemas.openxmlformats.org/drawingml/2006/main">
             <a:pPr algn="ctr">
+              <a:buNone/>
               <a:defRPr sz="2100" b="1">
                 <a:solidFill>
                   <a:srgbClr val="101114"/>
@@ -5079,6 +5990,7 @@
           <a:lstStyle xmlns:a="http://schemas.openxmlformats.org/drawingml/2006/main"/>
           <a:p xmlns:a="http://schemas.openxmlformats.org/drawingml/2006/main">
             <a:pPr algn="ctr">
+              <a:buNone/>
               <a:defRPr sz="1200" b="1">
                 <a:solidFill>
                   <a:srgbClr val="101114"/>
@@ -5172,6 +6084,7 @@
           <a:lstStyle xmlns:a="http://schemas.openxmlformats.org/drawingml/2006/main"/>
           <a:p xmlns:a="http://schemas.openxmlformats.org/drawingml/2006/main">
             <a:pPr algn="ctr">
+              <a:buNone/>
               <a:defRPr sz="2100" b="1">
                 <a:solidFill>
                   <a:srgbClr val="101114"/>
@@ -5230,6 +6143,7 @@
           <a:lstStyle xmlns:a="http://schemas.openxmlformats.org/drawingml/2006/main"/>
           <a:p xmlns:a="http://schemas.openxmlformats.org/drawingml/2006/main">
             <a:pPr algn="ctr">
+              <a:buNone/>
               <a:defRPr sz="1200" b="1">
                 <a:solidFill>
                   <a:srgbClr val="101114"/>
@@ -5288,6 +6202,7 @@
           <a:lstStyle xmlns:a="http://schemas.openxmlformats.org/drawingml/2006/main"/>
           <a:p xmlns:a="http://schemas.openxmlformats.org/drawingml/2006/main">
             <a:pPr algn="ctr">
+              <a:buNone/>
               <a:defRPr sz="2175" b="1">
                 <a:solidFill>
                   <a:srgbClr val="101114"/>
@@ -5368,6 +6283,7 @@
           <a:lstStyle xmlns:a="http://schemas.openxmlformats.org/drawingml/2006/main"/>
           <a:p xmlns:a="http://schemas.openxmlformats.org/drawingml/2006/main">
             <a:pPr>
+              <a:buNone/>
               <a:defRPr sz="1125" b="1">
                 <a:solidFill>
                   <a:srgbClr val="3D8DFF"/>
@@ -5426,6 +6342,7 @@
           <a:lstStyle xmlns:a="http://schemas.openxmlformats.org/drawingml/2006/main"/>
           <a:p xmlns:a="http://schemas.openxmlformats.org/drawingml/2006/main">
             <a:pPr>
+              <a:buNone/>
               <a:defRPr sz="3600" b="1">
                 <a:solidFill>
                   <a:srgbClr val="101114"/>
@@ -5484,6 +6401,7 @@
           <a:lstStyle xmlns:a="http://schemas.openxmlformats.org/drawingml/2006/main"/>
           <a:p xmlns:a="http://schemas.openxmlformats.org/drawingml/2006/main">
             <a:pPr algn="r">
+              <a:buNone/>
               <a:defRPr sz="1050">
                 <a:solidFill>
                   <a:srgbClr val="5F6672"/>
@@ -5509,14 +6427,14 @@
       </p:sp>
       <p:pic>
         <p:nvPicPr>
-          <p:cNvPr id="10" name=""/>
+          <p:cNvPr id="12" name=""/>
           <p:cNvPicPr>
             <a:picLocks xmlns:a="http://schemas.openxmlformats.org/drawingml/2006/main" noChangeAspect="1"/>
           </p:cNvPicPr>
           <p:nvPr/>
         </p:nvPicPr>
         <p:blipFill>
-          <a:blip xmlns:r="http://schemas.openxmlformats.org/officeDocument/2006/relationships" xmlns:a="http://schemas.openxmlformats.org/drawingml/2006/main" r:embed="Rbf80e44d174841c8"/>
+          <a:blip xmlns:r="http://schemas.openxmlformats.org/officeDocument/2006/relationships" xmlns:a="http://schemas.openxmlformats.org/drawingml/2006/main" r:embed="R653533fd00c44cfb"/>
           <a:stretch xmlns:a="http://schemas.openxmlformats.org/drawingml/2006/main"/>
         </p:blipFill>
         <p:spPr>
@@ -5564,6 +6482,7 @@
           <a:lstStyle xmlns:a="http://schemas.openxmlformats.org/drawingml/2006/main"/>
           <a:p xmlns:a="http://schemas.openxmlformats.org/drawingml/2006/main">
             <a:pPr>
+              <a:buNone/>
               <a:defRPr sz="2175" b="1">
                 <a:solidFill>
                   <a:srgbClr val="101114"/>
@@ -5622,6 +6541,7 @@
           <a:lstStyle xmlns:a="http://schemas.openxmlformats.org/drawingml/2006/main"/>
           <a:p xmlns:a="http://schemas.openxmlformats.org/drawingml/2006/main">
             <a:pPr>
+              <a:buNone/>
               <a:defRPr sz="1500">
                 <a:solidFill>
                   <a:srgbClr val="5F6672"/>
@@ -5640,7 +6560,7 @@
                 <a:ea typeface="Helvetica Neue"/>
                 <a:cs typeface="Helvetica Neue"/>
               </a:rPr>
-              <a:t>Registration staff can search, consent and check in.</a:t>
+              <a:t>Registration staff can search, register and check in.</a:t>
             </a:r>
           </a:p>
           <a:p xmlns:a="http://schemas.openxmlformats.org/drawingml/2006/main">
@@ -5650,6 +6570,7 @@
           </a:p>
           <a:p xmlns:a="http://schemas.openxmlformats.org/drawingml/2006/main">
             <a:pPr>
+              <a:buNone/>
               <a:defRPr sz="1500">
                 <a:solidFill>
                   <a:srgbClr val="5F6672"/>
@@ -5678,6 +6599,7 @@
           </a:p>
           <a:p xmlns:a="http://schemas.openxmlformats.org/drawingml/2006/main">
             <a:pPr>
+              <a:buNone/>
               <a:defRPr sz="1500">
                 <a:solidFill>
                   <a:srgbClr val="5F6672"/>
@@ -5758,6 +6680,7 @@
           <a:lstStyle xmlns:a="http://schemas.openxmlformats.org/drawingml/2006/main"/>
           <a:p xmlns:a="http://schemas.openxmlformats.org/drawingml/2006/main">
             <a:pPr>
+              <a:buNone/>
               <a:defRPr sz="1125" b="1">
                 <a:solidFill>
                   <a:srgbClr val="3D8DFF"/>
@@ -5816,6 +6739,7 @@
           <a:lstStyle xmlns:a="http://schemas.openxmlformats.org/drawingml/2006/main"/>
           <a:p xmlns:a="http://schemas.openxmlformats.org/drawingml/2006/main">
             <a:pPr>
+              <a:buNone/>
               <a:defRPr sz="3600" b="1">
                 <a:solidFill>
                   <a:srgbClr val="101114"/>
@@ -5874,6 +6798,7 @@
           <a:lstStyle xmlns:a="http://schemas.openxmlformats.org/drawingml/2006/main"/>
           <a:p xmlns:a="http://schemas.openxmlformats.org/drawingml/2006/main">
             <a:pPr algn="r">
+              <a:buNone/>
               <a:defRPr sz="1050">
                 <a:solidFill>
                   <a:srgbClr val="5F6672"/>
@@ -6091,6 +7016,7 @@
           <a:lstStyle xmlns:a="http://schemas.openxmlformats.org/drawingml/2006/main"/>
           <a:p xmlns:a="http://schemas.openxmlformats.org/drawingml/2006/main">
             <a:pPr algn="ctr">
+              <a:buNone/>
               <a:defRPr sz="1875" b="1">
                 <a:solidFill>
                   <a:srgbClr val="101114"/>
@@ -6149,6 +7075,7 @@
           <a:lstStyle xmlns:a="http://schemas.openxmlformats.org/drawingml/2006/main"/>
           <a:p xmlns:a="http://schemas.openxmlformats.org/drawingml/2006/main">
             <a:pPr algn="ctr">
+              <a:buNone/>
               <a:defRPr sz="1275">
                 <a:solidFill>
                   <a:srgbClr val="5F6672"/>
@@ -6242,6 +7169,7 @@
           <a:lstStyle xmlns:a="http://schemas.openxmlformats.org/drawingml/2006/main"/>
           <a:p xmlns:a="http://schemas.openxmlformats.org/drawingml/2006/main">
             <a:pPr algn="ctr">
+              <a:buNone/>
               <a:defRPr sz="1875" b="1">
                 <a:solidFill>
                   <a:srgbClr val="101114"/>
@@ -6300,6 +7228,7 @@
           <a:lstStyle xmlns:a="http://schemas.openxmlformats.org/drawingml/2006/main"/>
           <a:p xmlns:a="http://schemas.openxmlformats.org/drawingml/2006/main">
             <a:pPr algn="ctr">
+              <a:buNone/>
               <a:defRPr sz="1275">
                 <a:solidFill>
                   <a:srgbClr val="5F6672"/>
@@ -6393,6 +7322,7 @@
           <a:lstStyle xmlns:a="http://schemas.openxmlformats.org/drawingml/2006/main"/>
           <a:p xmlns:a="http://schemas.openxmlformats.org/drawingml/2006/main">
             <a:pPr algn="ctr">
+              <a:buNone/>
               <a:defRPr sz="1875" b="1">
                 <a:solidFill>
                   <a:srgbClr val="101114"/>
@@ -6451,6 +7381,7 @@
           <a:lstStyle xmlns:a="http://schemas.openxmlformats.org/drawingml/2006/main"/>
           <a:p xmlns:a="http://schemas.openxmlformats.org/drawingml/2006/main">
             <a:pPr algn="ctr">
+              <a:buNone/>
               <a:defRPr sz="1275">
                 <a:solidFill>
                   <a:srgbClr val="5F6672"/>
@@ -6544,6 +7475,7 @@
           <a:lstStyle xmlns:a="http://schemas.openxmlformats.org/drawingml/2006/main"/>
           <a:p xmlns:a="http://schemas.openxmlformats.org/drawingml/2006/main">
             <a:pPr algn="ctr">
+              <a:buNone/>
               <a:defRPr sz="1875" b="1">
                 <a:solidFill>
                   <a:srgbClr val="101114"/>
@@ -6602,6 +7534,7 @@
           <a:lstStyle xmlns:a="http://schemas.openxmlformats.org/drawingml/2006/main"/>
           <a:p xmlns:a="http://schemas.openxmlformats.org/drawingml/2006/main">
             <a:pPr algn="ctr">
+              <a:buNone/>
               <a:defRPr sz="1275">
                 <a:solidFill>
                   <a:srgbClr val="5F6672"/>
@@ -6695,6 +7628,7 @@
           <a:lstStyle xmlns:a="http://schemas.openxmlformats.org/drawingml/2006/main"/>
           <a:p xmlns:a="http://schemas.openxmlformats.org/drawingml/2006/main">
             <a:pPr algn="ctr">
+              <a:buNone/>
               <a:defRPr sz="1875" b="1">
                 <a:solidFill>
                   <a:srgbClr val="101114"/>
@@ -6753,6 +7687,7 @@
           <a:lstStyle xmlns:a="http://schemas.openxmlformats.org/drawingml/2006/main"/>
           <a:p xmlns:a="http://schemas.openxmlformats.org/drawingml/2006/main">
             <a:pPr algn="ctr">
+              <a:buNone/>
               <a:defRPr sz="1275">
                 <a:solidFill>
                   <a:srgbClr val="5F6672"/>
@@ -6811,6 +7746,7 @@
           <a:lstStyle xmlns:a="http://schemas.openxmlformats.org/drawingml/2006/main"/>
           <a:p xmlns:a="http://schemas.openxmlformats.org/drawingml/2006/main">
             <a:pPr algn="ctr">
+              <a:buNone/>
               <a:defRPr sz="2100" b="1">
                 <a:solidFill>
                   <a:srgbClr val="B42318"/>
@@ -6891,6 +7827,7 @@
           <a:lstStyle xmlns:a="http://schemas.openxmlformats.org/drawingml/2006/main"/>
           <a:p xmlns:a="http://schemas.openxmlformats.org/drawingml/2006/main">
             <a:pPr>
+              <a:buNone/>
               <a:defRPr sz="1125" b="1">
                 <a:solidFill>
                   <a:srgbClr val="3D8DFF"/>
@@ -6949,6 +7886,7 @@
           <a:lstStyle xmlns:a="http://schemas.openxmlformats.org/drawingml/2006/main"/>
           <a:p xmlns:a="http://schemas.openxmlformats.org/drawingml/2006/main">
             <a:pPr>
+              <a:buNone/>
               <a:defRPr sz="3600" b="1">
                 <a:solidFill>
                   <a:srgbClr val="101114"/>
@@ -7007,6 +7945,7 @@
           <a:lstStyle xmlns:a="http://schemas.openxmlformats.org/drawingml/2006/main"/>
           <a:p xmlns:a="http://schemas.openxmlformats.org/drawingml/2006/main">
             <a:pPr algn="r">
+              <a:buNone/>
               <a:defRPr sz="1050">
                 <a:solidFill>
                   <a:srgbClr val="5F6672"/>
@@ -7065,6 +8004,7 @@
           <a:lstStyle xmlns:a="http://schemas.openxmlformats.org/drawingml/2006/main"/>
           <a:p xmlns:a="http://schemas.openxmlformats.org/drawingml/2006/main">
             <a:pPr>
+              <a:buNone/>
               <a:defRPr sz="3375" b="1">
                 <a:solidFill>
                   <a:srgbClr val="101114"/>
@@ -7123,6 +8063,7 @@
           <a:lstStyle xmlns:a="http://schemas.openxmlformats.org/drawingml/2006/main"/>
           <a:p xmlns:a="http://schemas.openxmlformats.org/drawingml/2006/main">
             <a:pPr>
+              <a:buNone/>
               <a:defRPr sz="2175" b="1">
                 <a:solidFill>
                   <a:srgbClr val="101114"/>
@@ -7181,6 +8122,7 @@
           <a:lstStyle xmlns:a="http://schemas.openxmlformats.org/drawingml/2006/main"/>
           <a:p xmlns:a="http://schemas.openxmlformats.org/drawingml/2006/main">
             <a:pPr>
+              <a:buNone/>
               <a:defRPr sz="1575">
                 <a:solidFill>
                   <a:srgbClr val="5F6672"/>
@@ -7270,6 +8212,7 @@
           <a:lstStyle xmlns:a="http://schemas.openxmlformats.org/drawingml/2006/main"/>
           <a:p xmlns:a="http://schemas.openxmlformats.org/drawingml/2006/main">
             <a:pPr>
+              <a:buNone/>
               <a:defRPr sz="3375" b="1">
                 <a:solidFill>
                   <a:srgbClr val="101114"/>
@@ -7328,6 +8271,7 @@
           <a:lstStyle xmlns:a="http://schemas.openxmlformats.org/drawingml/2006/main"/>
           <a:p xmlns:a="http://schemas.openxmlformats.org/drawingml/2006/main">
             <a:pPr>
+              <a:buNone/>
               <a:defRPr sz="2175" b="1">
                 <a:solidFill>
                   <a:srgbClr val="101114"/>
@@ -7386,6 +8330,7 @@
           <a:lstStyle xmlns:a="http://schemas.openxmlformats.org/drawingml/2006/main"/>
           <a:p xmlns:a="http://schemas.openxmlformats.org/drawingml/2006/main">
             <a:pPr>
+              <a:buNone/>
               <a:defRPr sz="1575">
                 <a:solidFill>
                   <a:srgbClr val="5F6672"/>
@@ -7475,6 +8420,7 @@
           <a:lstStyle xmlns:a="http://schemas.openxmlformats.org/drawingml/2006/main"/>
           <a:p xmlns:a="http://schemas.openxmlformats.org/drawingml/2006/main">
             <a:pPr>
+              <a:buNone/>
               <a:defRPr sz="3375" b="1">
                 <a:solidFill>
                   <a:srgbClr val="101114"/>
@@ -7533,6 +8479,7 @@
           <a:lstStyle xmlns:a="http://schemas.openxmlformats.org/drawingml/2006/main"/>
           <a:p xmlns:a="http://schemas.openxmlformats.org/drawingml/2006/main">
             <a:pPr>
+              <a:buNone/>
               <a:defRPr sz="2175" b="1">
                 <a:solidFill>
                   <a:srgbClr val="101114"/>
@@ -7591,6 +8538,7 @@
           <a:lstStyle xmlns:a="http://schemas.openxmlformats.org/drawingml/2006/main"/>
           <a:p xmlns:a="http://schemas.openxmlformats.org/drawingml/2006/main">
             <a:pPr>
+              <a:buNone/>
               <a:defRPr sz="1575">
                 <a:solidFill>
                   <a:srgbClr val="5F6672"/>
@@ -7680,6 +8628,7 @@
           <a:lstStyle xmlns:a="http://schemas.openxmlformats.org/drawingml/2006/main"/>
           <a:p xmlns:a="http://schemas.openxmlformats.org/drawingml/2006/main">
             <a:pPr>
+              <a:buNone/>
               <a:defRPr sz="3375" b="1">
                 <a:solidFill>
                   <a:srgbClr val="3D8DFF"/>
@@ -7738,6 +8687,7 @@
           <a:lstStyle xmlns:a="http://schemas.openxmlformats.org/drawingml/2006/main"/>
           <a:p xmlns:a="http://schemas.openxmlformats.org/drawingml/2006/main">
             <a:pPr>
+              <a:buNone/>
               <a:defRPr sz="2175" b="1">
                 <a:solidFill>
                   <a:srgbClr val="101114"/>
@@ -7796,6 +8746,7 @@
           <a:lstStyle xmlns:a="http://schemas.openxmlformats.org/drawingml/2006/main"/>
           <a:p xmlns:a="http://schemas.openxmlformats.org/drawingml/2006/main">
             <a:pPr>
+              <a:buNone/>
               <a:defRPr sz="1575">
                 <a:solidFill>
                   <a:srgbClr val="5F6672"/>
@@ -7907,6 +8858,7 @@
           <a:lstStyle xmlns:a="http://schemas.openxmlformats.org/drawingml/2006/main"/>
           <a:p xmlns:a="http://schemas.openxmlformats.org/drawingml/2006/main">
             <a:pPr>
+              <a:buNone/>
               <a:defRPr sz="1125" b="1">
                 <a:solidFill>
                   <a:srgbClr val="3D8DFF"/>
@@ -7965,6 +8917,7 @@
           <a:lstStyle xmlns:a="http://schemas.openxmlformats.org/drawingml/2006/main"/>
           <a:p xmlns:a="http://schemas.openxmlformats.org/drawingml/2006/main">
             <a:pPr>
+              <a:buNone/>
               <a:defRPr sz="3600" b="1">
                 <a:solidFill>
                   <a:srgbClr val="101114"/>
@@ -8023,6 +8976,7 @@
           <a:lstStyle xmlns:a="http://schemas.openxmlformats.org/drawingml/2006/main"/>
           <a:p xmlns:a="http://schemas.openxmlformats.org/drawingml/2006/main">
             <a:pPr algn="r">
+              <a:buNone/>
               <a:defRPr sz="1050">
                 <a:solidFill>
                   <a:srgbClr val="5F6672"/>
@@ -8240,6 +9194,7 @@
           <a:lstStyle xmlns:a="http://schemas.openxmlformats.org/drawingml/2006/main"/>
           <a:p xmlns:a="http://schemas.openxmlformats.org/drawingml/2006/main">
             <a:pPr algn="ctr">
+              <a:buNone/>
               <a:defRPr sz="1725" b="1">
                 <a:solidFill>
                   <a:srgbClr val="101114"/>
@@ -8298,6 +9253,7 @@
           <a:lstStyle xmlns:a="http://schemas.openxmlformats.org/drawingml/2006/main"/>
           <a:p xmlns:a="http://schemas.openxmlformats.org/drawingml/2006/main">
             <a:pPr algn="ctr">
+              <a:buNone/>
               <a:defRPr sz="1275">
                 <a:solidFill>
                   <a:srgbClr val="5F6672"/>
@@ -8391,6 +9347,7 @@
           <a:lstStyle xmlns:a="http://schemas.openxmlformats.org/drawingml/2006/main"/>
           <a:p xmlns:a="http://schemas.openxmlformats.org/drawingml/2006/main">
             <a:pPr algn="ctr">
+              <a:buNone/>
               <a:defRPr sz="1725" b="1">
                 <a:solidFill>
                   <a:srgbClr val="101114"/>
@@ -8449,6 +9406,7 @@
           <a:lstStyle xmlns:a="http://schemas.openxmlformats.org/drawingml/2006/main"/>
           <a:p xmlns:a="http://schemas.openxmlformats.org/drawingml/2006/main">
             <a:pPr algn="ctr">
+              <a:buNone/>
               <a:defRPr sz="1275">
                 <a:solidFill>
                   <a:srgbClr val="5F6672"/>
@@ -8542,6 +9500,7 @@
           <a:lstStyle xmlns:a="http://schemas.openxmlformats.org/drawingml/2006/main"/>
           <a:p xmlns:a="http://schemas.openxmlformats.org/drawingml/2006/main">
             <a:pPr algn="ctr">
+              <a:buNone/>
               <a:defRPr sz="1725" b="1">
                 <a:solidFill>
                   <a:srgbClr val="101114"/>
@@ -8600,6 +9559,7 @@
           <a:lstStyle xmlns:a="http://schemas.openxmlformats.org/drawingml/2006/main"/>
           <a:p xmlns:a="http://schemas.openxmlformats.org/drawingml/2006/main">
             <a:pPr algn="ctr">
+              <a:buNone/>
               <a:defRPr sz="1275">
                 <a:solidFill>
                   <a:srgbClr val="5F6672"/>
@@ -8693,6 +9653,7 @@
           <a:lstStyle xmlns:a="http://schemas.openxmlformats.org/drawingml/2006/main"/>
           <a:p xmlns:a="http://schemas.openxmlformats.org/drawingml/2006/main">
             <a:pPr algn="ctr">
+              <a:buNone/>
               <a:defRPr sz="1725" b="1">
                 <a:solidFill>
                   <a:srgbClr val="101114"/>
@@ -8751,6 +9712,7 @@
           <a:lstStyle xmlns:a="http://schemas.openxmlformats.org/drawingml/2006/main"/>
           <a:p xmlns:a="http://schemas.openxmlformats.org/drawingml/2006/main">
             <a:pPr algn="ctr">
+              <a:buNone/>
               <a:defRPr sz="1275">
                 <a:solidFill>
                   <a:srgbClr val="5F6672"/>
@@ -8844,6 +9806,7 @@
           <a:lstStyle xmlns:a="http://schemas.openxmlformats.org/drawingml/2006/main"/>
           <a:p xmlns:a="http://schemas.openxmlformats.org/drawingml/2006/main">
             <a:pPr algn="ctr">
+              <a:buNone/>
               <a:defRPr sz="1725" b="1">
                 <a:solidFill>
                   <a:srgbClr val="101114"/>
@@ -8902,6 +9865,7 @@
           <a:lstStyle xmlns:a="http://schemas.openxmlformats.org/drawingml/2006/main"/>
           <a:p xmlns:a="http://schemas.openxmlformats.org/drawingml/2006/main">
             <a:pPr algn="ctr">
+              <a:buNone/>
               <a:defRPr sz="1275">
                 <a:solidFill>
                   <a:srgbClr val="5F6672"/>
@@ -8960,6 +9924,7 @@
           <a:lstStyle xmlns:a="http://schemas.openxmlformats.org/drawingml/2006/main"/>
           <a:p xmlns:a="http://schemas.openxmlformats.org/drawingml/2006/main">
             <a:pPr algn="ctr">
+              <a:buNone/>
               <a:defRPr sz="1875" b="1">
                 <a:solidFill>
                   <a:srgbClr val="101114"/>
@@ -9040,6 +10005,7 @@
           <a:lstStyle xmlns:a="http://schemas.openxmlformats.org/drawingml/2006/main"/>
           <a:p xmlns:a="http://schemas.openxmlformats.org/drawingml/2006/main">
             <a:pPr>
+              <a:buNone/>
               <a:defRPr sz="1125" b="1">
                 <a:solidFill>
                   <a:srgbClr val="3D8DFF"/>
@@ -9098,6 +10064,7 @@
           <a:lstStyle xmlns:a="http://schemas.openxmlformats.org/drawingml/2006/main"/>
           <a:p xmlns:a="http://schemas.openxmlformats.org/drawingml/2006/main">
             <a:pPr>
+              <a:buNone/>
               <a:defRPr sz="3600" b="1">
                 <a:solidFill>
                   <a:srgbClr val="101114"/>
@@ -9156,6 +10123,7 @@
           <a:lstStyle xmlns:a="http://schemas.openxmlformats.org/drawingml/2006/main"/>
           <a:p xmlns:a="http://schemas.openxmlformats.org/drawingml/2006/main">
             <a:pPr algn="r">
+              <a:buNone/>
               <a:defRPr sz="1050">
                 <a:solidFill>
                   <a:srgbClr val="5F6672"/>
@@ -9181,14 +10149,14 @@
       </p:sp>
       <p:pic>
         <p:nvPicPr>
-          <p:cNvPr id="12" name=""/>
+          <p:cNvPr id="14" name=""/>
           <p:cNvPicPr>
             <a:picLocks xmlns:a="http://schemas.openxmlformats.org/drawingml/2006/main" noChangeAspect="1"/>
           </p:cNvPicPr>
           <p:nvPr/>
         </p:nvPicPr>
         <p:blipFill>
-          <a:blip xmlns:r="http://schemas.openxmlformats.org/officeDocument/2006/relationships" xmlns:a="http://schemas.openxmlformats.org/drawingml/2006/main" r:embed="R89302a0fdf8843ee"/>
+          <a:blip xmlns:r="http://schemas.openxmlformats.org/officeDocument/2006/relationships" xmlns:a="http://schemas.openxmlformats.org/drawingml/2006/main" r:embed="R57f3a5db5dd7481f"/>
           <a:stretch xmlns:a="http://schemas.openxmlformats.org/drawingml/2006/main"/>
         </p:blipFill>
         <p:spPr>
@@ -9236,6 +10204,7 @@
           <a:lstStyle xmlns:a="http://schemas.openxmlformats.org/drawingml/2006/main"/>
           <a:p xmlns:a="http://schemas.openxmlformats.org/drawingml/2006/main">
             <a:pPr>
+              <a:buNone/>
               <a:defRPr sz="2550" b="1">
                 <a:solidFill>
                   <a:srgbClr val="101114"/>
@@ -9294,6 +10263,7 @@
           <a:lstStyle xmlns:a="http://schemas.openxmlformats.org/drawingml/2006/main"/>
           <a:p xmlns:a="http://schemas.openxmlformats.org/drawingml/2006/main">
             <a:pPr>
+              <a:buNone/>
               <a:defRPr sz="1650">
                 <a:solidFill>
                   <a:srgbClr val="5F6672"/>
@@ -9352,6 +10322,7 @@
           <a:lstStyle xmlns:a="http://schemas.openxmlformats.org/drawingml/2006/main"/>
           <a:p xmlns:a="http://schemas.openxmlformats.org/drawingml/2006/main">
             <a:pPr>
+              <a:buNone/>
               <a:defRPr sz="2550" b="1">
                 <a:solidFill>
                   <a:srgbClr val="3D8DFF"/>
@@ -9410,6 +10381,7 @@
           <a:lstStyle xmlns:a="http://schemas.openxmlformats.org/drawingml/2006/main"/>
           <a:p xmlns:a="http://schemas.openxmlformats.org/drawingml/2006/main">
             <a:pPr>
+              <a:buNone/>
               <a:defRPr sz="1650">
                 <a:solidFill>
                   <a:srgbClr val="5F6672"/>
@@ -9490,6 +10462,7 @@
           <a:lstStyle xmlns:a="http://schemas.openxmlformats.org/drawingml/2006/main"/>
           <a:p xmlns:a="http://schemas.openxmlformats.org/drawingml/2006/main">
             <a:pPr>
+              <a:buNone/>
               <a:defRPr sz="1125" b="1">
                 <a:solidFill>
                   <a:srgbClr val="3D8DFF"/>
@@ -9548,6 +10521,7 @@
           <a:lstStyle xmlns:a="http://schemas.openxmlformats.org/drawingml/2006/main"/>
           <a:p xmlns:a="http://schemas.openxmlformats.org/drawingml/2006/main">
             <a:pPr>
+              <a:buNone/>
               <a:defRPr sz="3600" b="1">
                 <a:solidFill>
                   <a:srgbClr val="101114"/>
@@ -9606,6 +10580,7 @@
           <a:lstStyle xmlns:a="http://schemas.openxmlformats.org/drawingml/2006/main"/>
           <a:p xmlns:a="http://schemas.openxmlformats.org/drawingml/2006/main">
             <a:pPr algn="r">
+              <a:buNone/>
               <a:defRPr sz="1050">
                 <a:solidFill>
                   <a:srgbClr val="5F6672"/>
@@ -9823,6 +10798,7 @@
           <a:lstStyle xmlns:a="http://schemas.openxmlformats.org/drawingml/2006/main"/>
           <a:p xmlns:a="http://schemas.openxmlformats.org/drawingml/2006/main">
             <a:pPr algn="ctr">
+              <a:buNone/>
               <a:defRPr sz="1800" b="1">
                 <a:solidFill>
                   <a:srgbClr val="101114"/>
@@ -9881,6 +10857,7 @@
           <a:lstStyle xmlns:a="http://schemas.openxmlformats.org/drawingml/2006/main"/>
           <a:p xmlns:a="http://schemas.openxmlformats.org/drawingml/2006/main">
             <a:pPr algn="ctr">
+              <a:buNone/>
               <a:defRPr sz="1200">
                 <a:solidFill>
                   <a:srgbClr val="5F6672"/>
@@ -9974,6 +10951,7 @@
           <a:lstStyle xmlns:a="http://schemas.openxmlformats.org/drawingml/2006/main"/>
           <a:p xmlns:a="http://schemas.openxmlformats.org/drawingml/2006/main">
             <a:pPr algn="ctr">
+              <a:buNone/>
               <a:defRPr sz="1800" b="1">
                 <a:solidFill>
                   <a:srgbClr val="101114"/>
@@ -10032,6 +11010,7 @@
           <a:lstStyle xmlns:a="http://schemas.openxmlformats.org/drawingml/2006/main"/>
           <a:p xmlns:a="http://schemas.openxmlformats.org/drawingml/2006/main">
             <a:pPr algn="ctr">
+              <a:buNone/>
               <a:defRPr sz="1200">
                 <a:solidFill>
                   <a:srgbClr val="5F6672"/>
@@ -10125,6 +11104,7 @@
           <a:lstStyle xmlns:a="http://schemas.openxmlformats.org/drawingml/2006/main"/>
           <a:p xmlns:a="http://schemas.openxmlformats.org/drawingml/2006/main">
             <a:pPr algn="ctr">
+              <a:buNone/>
               <a:defRPr sz="1800" b="1">
                 <a:solidFill>
                   <a:srgbClr val="101114"/>
@@ -10183,6 +11163,7 @@
           <a:lstStyle xmlns:a="http://schemas.openxmlformats.org/drawingml/2006/main"/>
           <a:p xmlns:a="http://schemas.openxmlformats.org/drawingml/2006/main">
             <a:pPr algn="ctr">
+              <a:buNone/>
               <a:defRPr sz="1200">
                 <a:solidFill>
                   <a:srgbClr val="5F6672"/>
@@ -10276,6 +11257,7 @@
           <a:lstStyle xmlns:a="http://schemas.openxmlformats.org/drawingml/2006/main"/>
           <a:p xmlns:a="http://schemas.openxmlformats.org/drawingml/2006/main">
             <a:pPr algn="ctr">
+              <a:buNone/>
               <a:defRPr sz="1800" b="1">
                 <a:solidFill>
                   <a:srgbClr val="101114"/>
@@ -10334,6 +11316,7 @@
           <a:lstStyle xmlns:a="http://schemas.openxmlformats.org/drawingml/2006/main"/>
           <a:p xmlns:a="http://schemas.openxmlformats.org/drawingml/2006/main">
             <a:pPr algn="ctr">
+              <a:buNone/>
               <a:defRPr sz="1200">
                 <a:solidFill>
                   <a:srgbClr val="5F6672"/>
@@ -10427,6 +11410,7 @@
           <a:lstStyle xmlns:a="http://schemas.openxmlformats.org/drawingml/2006/main"/>
           <a:p xmlns:a="http://schemas.openxmlformats.org/drawingml/2006/main">
             <a:pPr algn="ctr">
+              <a:buNone/>
               <a:defRPr sz="1800" b="1">
                 <a:solidFill>
                   <a:srgbClr val="101114"/>
@@ -10485,6 +11469,7 @@
           <a:lstStyle xmlns:a="http://schemas.openxmlformats.org/drawingml/2006/main"/>
           <a:p xmlns:a="http://schemas.openxmlformats.org/drawingml/2006/main">
             <a:pPr algn="ctr">
+              <a:buNone/>
               <a:defRPr sz="1200">
                 <a:solidFill>
                   <a:srgbClr val="5F6672"/>
@@ -10543,6 +11528,7 @@
           <a:lstStyle xmlns:a="http://schemas.openxmlformats.org/drawingml/2006/main"/>
           <a:p xmlns:a="http://schemas.openxmlformats.org/drawingml/2006/main">
             <a:pPr algn="ctr">
+              <a:buNone/>
               <a:defRPr sz="1650" b="1">
                 <a:solidFill>
                   <a:srgbClr val="3D8DFF"/>
@@ -10601,6 +11587,7 @@
           <a:lstStyle xmlns:a="http://schemas.openxmlformats.org/drawingml/2006/main"/>
           <a:p xmlns:a="http://schemas.openxmlformats.org/drawingml/2006/main">
             <a:pPr algn="ctr">
+              <a:buNone/>
               <a:defRPr sz="2025" b="1">
                 <a:solidFill>
                   <a:srgbClr val="B42318"/>
@@ -10681,6 +11668,7 @@
           <a:lstStyle xmlns:a="http://schemas.openxmlformats.org/drawingml/2006/main"/>
           <a:p xmlns:a="http://schemas.openxmlformats.org/drawingml/2006/main">
             <a:pPr>
+              <a:buNone/>
               <a:defRPr sz="1125" b="1">
                 <a:solidFill>
                   <a:srgbClr val="3D8DFF"/>
@@ -10739,6 +11727,7 @@
           <a:lstStyle xmlns:a="http://schemas.openxmlformats.org/drawingml/2006/main"/>
           <a:p xmlns:a="http://schemas.openxmlformats.org/drawingml/2006/main">
             <a:pPr>
+              <a:buNone/>
               <a:defRPr sz="3600" b="1">
                 <a:solidFill>
                   <a:srgbClr val="101114"/>
@@ -10797,6 +11786,7 @@
           <a:lstStyle xmlns:a="http://schemas.openxmlformats.org/drawingml/2006/main"/>
           <a:p xmlns:a="http://schemas.openxmlformats.org/drawingml/2006/main">
             <a:pPr algn="r">
+              <a:buNone/>
               <a:defRPr sz="1050">
                 <a:solidFill>
                   <a:srgbClr val="5F6672"/>
@@ -10822,7 +11812,7 @@
       </p:sp>
       <p:graphicFrame>
         <p:nvGraphicFramePr>
-          <p:cNvPr id="13" name="Chart"/>
+          <p:cNvPr id="15" name="Chart"/>
           <p:cNvGraphicFramePr/>
           <p:nvPr/>
         </p:nvGraphicFramePr>
@@ -10832,7 +11822,7 @@
         </p:xfrm>
         <a:graphic xmlns:a="http://schemas.openxmlformats.org/drawingml/2006/main">
           <a:graphicData uri="http://schemas.openxmlformats.org/drawingml/2006/chart">
-            <c:chart xmlns:r="http://schemas.openxmlformats.org/officeDocument/2006/relationships" xmlns:c="http://schemas.openxmlformats.org/drawingml/2006/chart" r:id="Rfee0ab4e72e645f1"/>
+            <c:chart xmlns:r="http://schemas.openxmlformats.org/officeDocument/2006/relationships" xmlns:c="http://schemas.openxmlformats.org/drawingml/2006/chart" r:id="R04e2235c69ab42bf"/>
           </a:graphicData>
         </a:graphic>
       </p:graphicFrame>
@@ -10871,6 +11861,7 @@
           <a:lstStyle xmlns:a="http://schemas.openxmlformats.org/drawingml/2006/main"/>
           <a:p xmlns:a="http://schemas.openxmlformats.org/drawingml/2006/main">
             <a:pPr>
+              <a:buNone/>
               <a:defRPr sz="4950" b="1">
                 <a:solidFill>
                   <a:srgbClr val="14966A"/>
@@ -10929,6 +11920,7 @@
           <a:lstStyle xmlns:a="http://schemas.openxmlformats.org/drawingml/2006/main"/>
           <a:p xmlns:a="http://schemas.openxmlformats.org/drawingml/2006/main">
             <a:pPr>
+              <a:buNone/>
               <a:defRPr sz="1650">
                 <a:solidFill>
                   <a:srgbClr val="5F6672"/>
@@ -10987,6 +11979,7 @@
           <a:lstStyle xmlns:a="http://schemas.openxmlformats.org/drawingml/2006/main"/>
           <a:p xmlns:a="http://schemas.openxmlformats.org/drawingml/2006/main">
             <a:pPr>
+              <a:buNone/>
               <a:defRPr sz="4350" b="1">
                 <a:solidFill>
                   <a:srgbClr val="101114"/>
@@ -11045,6 +12038,7 @@
           <a:lstStyle xmlns:a="http://schemas.openxmlformats.org/drawingml/2006/main"/>
           <a:p xmlns:a="http://schemas.openxmlformats.org/drawingml/2006/main">
             <a:pPr>
+              <a:buNone/>
               <a:defRPr sz="1650">
                 <a:solidFill>
                   <a:srgbClr val="5F6672"/>
@@ -11103,6 +12097,7 @@
           <a:lstStyle xmlns:a="http://schemas.openxmlformats.org/drawingml/2006/main"/>
           <a:p xmlns:a="http://schemas.openxmlformats.org/drawingml/2006/main">
             <a:pPr>
+              <a:buNone/>
               <a:defRPr sz="1575" b="1">
                 <a:solidFill>
                   <a:srgbClr val="3D8DFF"/>

</xml_diff>